<commit_message>
fix: replace per-shape animation XML with slide transitions
Per-shape timing XML injection was corrupting .pptx files due to namespace
conflicts and schema ordering violations in the existing slide XML. Replaced
with slide-level transitions (fade/push/wipe) which python-pptx inserts at
the correct position, producing files PowerPoint can reliably open.

https://claude.ai/code/session_01Ku7J1XKnJyhda2UCdNL7n9
</commit_message>
<xml_diff>
--- a/input/test_corporate_redesigned.pptx
+++ b/input/test_corporate_redesigned.pptx
@@ -3157,32 +3157,9 @@
   <p:clrMapOvr>
     <a:masterClrMapping/>
   </p:clrMapOvr>
-  <p:timing>
-    <p:tnLst>
-      <p:par>
-        <p:cTn id="1" dur="indefinite" restart="whenNotActive" nodeType="tmRoot">
-          <p:childTnLst>
-            <p:par>
-              <p:cTn id="10" fill="hold" presetID="10" presetClass="entr" presetSubtype="0" dur="700" nodeType="clickEffect">
-                <p:stCondLst>
-                  <p:cond evt="onClick" delay="0"/>
-                </p:stCondLst>
-                <p:childTnLst/>
-              </p:cTn>
-            </p:par>
-            <p:par>
-              <p:cTn id="11" fill="hold" presetID="10" presetClass="entr" presetSubtype="0" dur="600" nodeType="clickEffect">
-                <p:stCondLst>
-                  <p:cond delay="200"/>
-                </p:stCondLst>
-                <p:childTnLst/>
-              </p:cTn>
-            </p:par>
-          </p:childTnLst>
-        </p:cTn>
-      </p:par>
-    </p:tnLst>
-  </p:timing>
+  <p:transition spd="med" dur="406">
+    <p:fade/>
+  </p:transition>
 </p:sld>
 </file>
 
@@ -3221,7 +3198,7 @@
           <a:p>
             <a:pPr algn="ctr"/>
             <a:r>
-              <a:rPr sz="3000" b="1" u="none">
+              <a:rPr sz="3200" b="1" u="none">
                 <a:solidFill>
                   <a:srgbClr val="1C2B3A"/>
                 </a:solidFill>
@@ -3292,8 +3269,8 @@
         </p:nvSpPr>
         <p:spPr>
           <a:xfrm>
-            <a:off x="760399" y="111625"/>
-            <a:ext cx="3023321" cy="36576"/>
+            <a:off x="659822" y="107221"/>
+            <a:ext cx="1620029" cy="36576"/>
           </a:xfrm>
           <a:prstGeom prst="rect">
             <a:avLst/>
@@ -3332,40 +3309,6 @@
   <p:clrMapOvr>
     <a:masterClrMapping/>
   </p:clrMapOvr>
-  <p:timing>
-    <p:tnLst>
-      <p:par>
-        <p:cTn id="1" dur="indefinite" restart="whenNotActive" nodeType="tmRoot">
-          <p:childTnLst>
-            <p:par>
-              <p:cTn id="10" fill="hold" presetID="10" presetClass="entr" presetSubtype="0" dur="600" nodeType="clickEffect">
-                <p:stCondLst>
-                  <p:cond evt="onClick" delay="0"/>
-                </p:stCondLst>
-                <p:childTnLst/>
-              </p:cTn>
-            </p:par>
-            <p:par>
-              <p:cTn id="11" fill="hold" presetID="10" presetClass="entr" presetSubtype="0" dur="600" nodeType="clickEffect">
-                <p:stCondLst>
-                  <p:cond delay="200"/>
-                </p:stCondLst>
-                <p:childTnLst/>
-              </p:cTn>
-            </p:par>
-            <p:par>
-              <p:cTn id="12" fill="hold" presetID="10" presetClass="entr" presetSubtype="0" dur="600" nodeType="clickEffect">
-                <p:stCondLst>
-                  <p:cond delay="400"/>
-                </p:stCondLst>
-                <p:childTnLst/>
-              </p:cTn>
-            </p:par>
-          </p:childTnLst>
-        </p:cTn>
-      </p:par>
-    </p:tnLst>
-  </p:timing>
 </p:sld>
 </file>
 
@@ -3404,7 +3347,7 @@
           <a:p>
             <a:pPr algn="l"/>
             <a:r>
-              <a:rPr sz="3000" b="1" u="none">
+              <a:rPr sz="2800" b="1" u="none">
                 <a:solidFill>
                   <a:srgbClr val="1C2B3A"/>
                 </a:solidFill>
@@ -3451,8 +3394,8 @@
         </p:nvSpPr>
         <p:spPr>
           <a:xfrm>
-            <a:off x="839258" y="105705"/>
-            <a:ext cx="1522261" cy="36576"/>
+            <a:off x="890476" y="89961"/>
+            <a:ext cx="2742428" cy="36576"/>
           </a:xfrm>
           <a:prstGeom prst="rect">
             <a:avLst/>
@@ -3529,7 +3472,7 @@
           <a:p>
             <a:pPr algn="l"/>
             <a:r>
-              <a:rPr sz="3200" b="1" u="none">
+              <a:rPr sz="2800" b="1" u="none">
                 <a:solidFill>
                   <a:srgbClr val="1C2B3A"/>
                 </a:solidFill>
@@ -3600,8 +3543,8 @@
         </p:nvSpPr>
         <p:spPr>
           <a:xfrm>
-            <a:off x="495991" y="102495"/>
-            <a:ext cx="1523299" cy="36576"/>
+            <a:off x="566293" y="135960"/>
+            <a:ext cx="2145983" cy="36576"/>
           </a:xfrm>
           <a:prstGeom prst="rect">
             <a:avLst/>
@@ -3640,6 +3583,9 @@
   <p:clrMapOvr>
     <a:masterClrMapping/>
   </p:clrMapOvr>
+  <p:transition spd="med" dur="465">
+    <p:fade/>
+  </p:transition>
 </p:sld>
 </file>
 
@@ -3713,32 +3659,9 @@
   <p:clrMapOvr>
     <a:masterClrMapping/>
   </p:clrMapOvr>
-  <p:timing>
-    <p:tnLst>
-      <p:par>
-        <p:cTn id="1" dur="indefinite" restart="whenNotActive" nodeType="tmRoot">
-          <p:childTnLst>
-            <p:par>
-              <p:cTn id="10" fill="hold" presetID="10" presetClass="entr" presetSubtype="0" dur="600" nodeType="clickEffect">
-                <p:stCondLst>
-                  <p:cond evt="onClick" delay="0"/>
-                </p:stCondLst>
-                <p:childTnLst/>
-              </p:cTn>
-            </p:par>
-            <p:par>
-              <p:cTn id="11" fill="hold" presetID="10" presetClass="entr" presetSubtype="0" dur="600" nodeType="clickEffect">
-                <p:stCondLst>
-                  <p:cond delay="200"/>
-                </p:stCondLst>
-                <p:childTnLst/>
-              </p:cTn>
-            </p:par>
-          </p:childTnLst>
-        </p:cTn>
-      </p:par>
-    </p:tnLst>
-  </p:timing>
+  <p:transition spd="med" dur="629">
+    <p:fade/>
+  </p:transition>
 </p:sld>
 </file>
 

</xml_diff>

<commit_message>
chore: update test output file
https://claude.ai/code/session_01Ku7J1XKnJyhda2UCdNL7n9
</commit_message>
<xml_diff>
--- a/input/test_corporate_redesigned.pptx
+++ b/input/test_corporate_redesigned.pptx
@@ -3110,21 +3110,15 @@
             <p:ph type="ctrTitle"/>
           </p:nvPr>
         </p:nvSpPr>
-        <p:spPr>
-          <a:xfrm>
-            <a:off x="548640" y="0"/>
-            <a:ext cx="6858000" cy="0"/>
-          </a:xfrm>
-        </p:spPr>
-        <p:txBody>
-          <a:bodyPr wrap="square"/>
-          <a:lstStyle/>
-          <a:p>
-            <a:pPr algn="l"/>
-            <a:r>
-              <a:rPr sz="4400" b="1" u="none">
+        <p:spPr/>
+        <p:txBody>
+          <a:bodyPr/>
+          <a:lstStyle/>
+          <a:p>
+            <a:r>
+              <a:rPr b="1">
                 <a:solidFill>
-                  <a:srgbClr val="1C2B3A"/>
+                  <a:srgbClr val="C8A84B"/>
                 </a:solidFill>
                 <a:latin typeface="Georgia"/>
               </a:rPr>
@@ -3145,11 +3139,9 @@
         </p:nvSpPr>
         <p:spPr/>
         <p:txBody>
-          <a:bodyPr wrap="square"/>
-          <a:lstStyle/>
-          <a:p>
-            <a:pPr algn="l"/>
-          </a:p>
+          <a:bodyPr/>
+          <a:lstStyle/>
+          <a:p/>
         </p:txBody>
       </p:sp>
     </p:spTree>
@@ -3157,7 +3149,7 @@
   <p:clrMapOvr>
     <a:masterClrMapping/>
   </p:clrMapOvr>
-  <p:transition spd="med" dur="406">
+  <p:transition spd="med" dur="429">
     <p:fade/>
   </p:transition>
 </p:sld>
@@ -3196,9 +3188,8 @@
           <a:bodyPr/>
           <a:lstStyle/>
           <a:p>
-            <a:pPr algn="ctr"/>
-            <a:r>
-              <a:rPr sz="3200" b="1" u="none">
+            <a:r>
+              <a:rPr b="1">
                 <a:solidFill>
                   <a:srgbClr val="1C2B3A"/>
                 </a:solidFill>
@@ -3224,9 +3215,8 @@
           <a:bodyPr/>
           <a:lstStyle/>
           <a:p>
-            <a:pPr algn="ctr"/>
-            <a:r>
-              <a:rPr sz="2000" b="0" u="none">
+            <a:r>
+              <a:rPr>
                 <a:solidFill>
                   <a:srgbClr val="1C2B3A"/>
                 </a:solidFill>
@@ -3236,9 +3226,8 @@
             </a:r>
           </a:p>
           <a:p>
-            <a:pPr algn="ctr"/>
-            <a:r>
-              <a:rPr sz="2000" b="0" u="none">
+            <a:r>
+              <a:rPr>
                 <a:solidFill>
                   <a:srgbClr val="1C2B3A"/>
                 </a:solidFill>
@@ -3248,9 +3237,8 @@
             </a:r>
           </a:p>
           <a:p>
-            <a:pPr algn="ctr"/>
-            <a:r>
-              <a:rPr sz="2000" b="0" u="none">
+            <a:r>
+              <a:rPr>
                 <a:solidFill>
                   <a:srgbClr val="1C2B3A"/>
                 </a:solidFill>
@@ -3269,8 +3257,8 @@
         </p:nvSpPr>
         <p:spPr>
           <a:xfrm>
-            <a:off x="659822" y="107221"/>
-            <a:ext cx="1620029" cy="36576"/>
+            <a:off x="0" y="0"/>
+            <a:ext cx="9144000" cy="76200"/>
           </a:xfrm>
           <a:prstGeom prst="rect">
             <a:avLst/>
@@ -3345,9 +3333,8 @@
           <a:bodyPr/>
           <a:lstStyle/>
           <a:p>
-            <a:pPr algn="l"/>
-            <a:r>
-              <a:rPr sz="2800" b="1" u="none">
+            <a:r>
+              <a:rPr b="1">
                 <a:solidFill>
                   <a:srgbClr val="1C2B3A"/>
                 </a:solidFill>
@@ -3373,9 +3360,8 @@
           <a:bodyPr/>
           <a:lstStyle/>
           <a:p>
-            <a:pPr algn="l"/>
-            <a:r>
-              <a:rPr sz="2000" b="0" u="none">
+            <a:r>
+              <a:rPr>
                 <a:solidFill>
                   <a:srgbClr val="1C2B3A"/>
                 </a:solidFill>
@@ -3394,8 +3380,8 @@
         </p:nvSpPr>
         <p:spPr>
           <a:xfrm>
-            <a:off x="890476" y="89961"/>
-            <a:ext cx="2742428" cy="36576"/>
+            <a:off x="0" y="0"/>
+            <a:ext cx="9144000" cy="76200"/>
           </a:xfrm>
           <a:prstGeom prst="rect">
             <a:avLst/>
@@ -3470,9 +3456,8 @@
           <a:bodyPr/>
           <a:lstStyle/>
           <a:p>
-            <a:pPr algn="l"/>
-            <a:r>
-              <a:rPr sz="2800" b="1" u="none">
+            <a:r>
+              <a:rPr b="1">
                 <a:solidFill>
                   <a:srgbClr val="1C2B3A"/>
                 </a:solidFill>
@@ -3498,9 +3483,8 @@
           <a:bodyPr/>
           <a:lstStyle/>
           <a:p>
-            <a:pPr algn="l"/>
-            <a:r>
-              <a:rPr sz="2000" b="0" u="none">
+            <a:r>
+              <a:rPr>
                 <a:solidFill>
                   <a:srgbClr val="1C2B3A"/>
                 </a:solidFill>
@@ -3510,9 +3494,8 @@
             </a:r>
           </a:p>
           <a:p>
-            <a:pPr algn="l"/>
-            <a:r>
-              <a:rPr sz="2000" b="0" u="none">
+            <a:r>
+              <a:rPr>
                 <a:solidFill>
                   <a:srgbClr val="1C2B3A"/>
                 </a:solidFill>
@@ -3522,9 +3505,8 @@
             </a:r>
           </a:p>
           <a:p>
-            <a:pPr algn="l"/>
-            <a:r>
-              <a:rPr sz="2000" b="0" u="none">
+            <a:r>
+              <a:rPr>
                 <a:solidFill>
                   <a:srgbClr val="1C2B3A"/>
                 </a:solidFill>
@@ -3543,8 +3525,8 @@
         </p:nvSpPr>
         <p:spPr>
           <a:xfrm>
-            <a:off x="566293" y="135960"/>
-            <a:ext cx="2145983" cy="36576"/>
+            <a:off x="0" y="0"/>
+            <a:ext cx="9144000" cy="76200"/>
           </a:xfrm>
           <a:prstGeom prst="rect">
             <a:avLst/>
@@ -3583,7 +3565,7 @@
   <p:clrMapOvr>
     <a:masterClrMapping/>
   </p:clrMapOvr>
-  <p:transition spd="med" dur="465">
+  <p:transition spd="med" dur="672">
     <p:fade/>
   </p:transition>
 </p:sld>
@@ -3622,9 +3604,8 @@
           <a:bodyPr/>
           <a:lstStyle/>
           <a:p>
-            <a:pPr algn="ctr"/>
-            <a:r>
-              <a:rPr sz="3600" b="1" u="none">
+            <a:r>
+              <a:rPr b="1">
                 <a:solidFill>
                   <a:srgbClr val="C8A84B"/>
                 </a:solidFill>
@@ -3649,6 +3630,47 @@
         <p:txBody>
           <a:bodyPr/>
           <a:lstStyle/>
+          <a:p/>
+        </p:txBody>
+      </p:sp>
+      <p:sp>
+        <p:nvSpPr>
+          <p:cNvPr id="4" name="Rectangle 3"/>
+          <p:cNvSpPr/>
+          <p:nvPr/>
+        </p:nvSpPr>
+        <p:spPr>
+          <a:xfrm>
+            <a:off x="0" y="0"/>
+            <a:ext cx="9144000" cy="76200"/>
+          </a:xfrm>
+          <a:prstGeom prst="rect">
+            <a:avLst/>
+          </a:prstGeom>
+          <a:solidFill>
+            <a:srgbClr val="C8A84B"/>
+          </a:solidFill>
+          <a:ln>
+            <a:noFill/>
+          </a:ln>
+        </p:spPr>
+        <p:style>
+          <a:lnRef idx="1">
+            <a:schemeClr val="accent1"/>
+          </a:lnRef>
+          <a:fillRef idx="3">
+            <a:schemeClr val="accent1"/>
+          </a:fillRef>
+          <a:effectRef idx="2">
+            <a:schemeClr val="accent1"/>
+          </a:effectRef>
+          <a:fontRef idx="minor">
+            <a:schemeClr val="lt1"/>
+          </a:fontRef>
+        </p:style>
+        <p:txBody>
+          <a:bodyPr rtlCol="0" anchor="ctr"/>
+          <a:lstStyle/>
           <a:p>
             <a:pPr algn="ctr"/>
           </a:p>
@@ -3659,7 +3681,7 @@
   <p:clrMapOvr>
     <a:masterClrMapping/>
   </p:clrMapOvr>
-  <p:transition spd="med" dur="629">
+  <p:transition spd="med" dur="662">
     <p:fade/>
   </p:transition>
 </p:sld>

</xml_diff>

<commit_message>
feat: strong visual transformation — title bands, typography scale, accent strips
- Imposed font size scale (52/48/36/22/18/15pt) regardless of source sizes
- Content slides: full-width colored title band (top 20%) placed behind shapes
- Title/closing slides: vertical accent strip left edge + bottom rule
- Section slides: accent band at bottom with white text on primary bg
- All decorative shapes inserted at z=0 (behind content) to avoid overlap

https://claude.ai/code/session_01Ku7J1XKnJyhda2UCdNL7n9
</commit_message>
<xml_diff>
--- a/input/test_corporate_redesigned.pptx
+++ b/input/test_corporate_redesigned.pptx
@@ -3116,7 +3116,7 @@
           <a:lstStyle/>
           <a:p>
             <a:r>
-              <a:rPr b="1">
+              <a:rPr sz="5200" b="1">
                 <a:solidFill>
                   <a:srgbClr val="C8A84B"/>
                 </a:solidFill>
@@ -3144,111 +3144,6 @@
           <a:p/>
         </p:txBody>
       </p:sp>
-    </p:spTree>
-  </p:cSld>
-  <p:clrMapOvr>
-    <a:masterClrMapping/>
-  </p:clrMapOvr>
-  <p:transition spd="med" dur="429">
-    <p:fade/>
-  </p:transition>
-</p:sld>
-</file>
-
-<file path=ppt/slides/slide2.xml><?xml version="1.0" encoding="utf-8"?>
-<p:sld xmlns:a="http://schemas.openxmlformats.org/drawingml/2006/main" xmlns:p="http://schemas.openxmlformats.org/presentationml/2006/main" xmlns:r="http://schemas.openxmlformats.org/officeDocument/2006/relationships">
-  <p:cSld>
-    <p:bg>
-      <p:bgPr>
-        <a:solidFill>
-          <a:srgbClr val="ECEAE3"/>
-        </a:solidFill>
-        <a:effectLst/>
-      </p:bgPr>
-    </p:bg>
-    <p:spTree>
-      <p:nvGrpSpPr>
-        <p:cNvPr id="1" name=""/>
-        <p:cNvGrpSpPr/>
-        <p:nvPr/>
-      </p:nvGrpSpPr>
-      <p:grpSpPr/>
-      <p:sp>
-        <p:nvSpPr>
-          <p:cNvPr id="2" name="Title 1"/>
-          <p:cNvSpPr>
-            <a:spLocks noGrp="1"/>
-          </p:cNvSpPr>
-          <p:nvPr>
-            <p:ph type="title"/>
-          </p:nvPr>
-        </p:nvSpPr>
-        <p:spPr/>
-        <p:txBody>
-          <a:bodyPr/>
-          <a:lstStyle/>
-          <a:p>
-            <a:r>
-              <a:rPr b="1">
-                <a:solidFill>
-                  <a:srgbClr val="1C2B3A"/>
-                </a:solidFill>
-                <a:latin typeface="Georgia"/>
-              </a:rPr>
-              <a:t>KPI Revenue</a:t>
-            </a:r>
-          </a:p>
-        </p:txBody>
-      </p:sp>
-      <p:sp>
-        <p:nvSpPr>
-          <p:cNvPr id="3" name="Content Placeholder 2"/>
-          <p:cNvSpPr>
-            <a:spLocks noGrp="1"/>
-          </p:cNvSpPr>
-          <p:nvPr>
-            <p:ph idx="1"/>
-          </p:nvPr>
-        </p:nvSpPr>
-        <p:spPr/>
-        <p:txBody>
-          <a:bodyPr/>
-          <a:lstStyle/>
-          <a:p>
-            <a:r>
-              <a:rPr>
-                <a:solidFill>
-                  <a:srgbClr val="1C2B3A"/>
-                </a:solidFill>
-                <a:latin typeface="Trebuchet MS"/>
-              </a:rPr>
-              <a:t>— Chiffre d'affaires +15%</a:t>
-            </a:r>
-          </a:p>
-          <a:p>
-            <a:r>
-              <a:rPr>
-                <a:solidFill>
-                  <a:srgbClr val="1C2B3A"/>
-                </a:solidFill>
-                <a:latin typeface="Trebuchet MS"/>
-              </a:rPr>
-              <a:t>— ROI amélioré</a:t>
-            </a:r>
-          </a:p>
-          <a:p>
-            <a:r>
-              <a:rPr>
-                <a:solidFill>
-                  <a:srgbClr val="1C2B3A"/>
-                </a:solidFill>
-                <a:latin typeface="Trebuchet MS"/>
-              </a:rPr>
-              <a:t>— Budget optimisé</a:t>
-            </a:r>
-          </a:p>
-        </p:txBody>
-      </p:sp>
       <p:sp>
         <p:nvSpPr>
           <p:cNvPr id="4" name="Rectangle 3"/>
@@ -3258,6 +3153,49 @@
         <p:spPr>
           <a:xfrm>
             <a:off x="0" y="0"/>
+            <a:ext cx="109728" cy="6858000"/>
+          </a:xfrm>
+          <a:prstGeom prst="rect">
+            <a:avLst/>
+          </a:prstGeom>
+          <a:solidFill>
+            <a:srgbClr val="C8A84B"/>
+          </a:solidFill>
+          <a:ln>
+            <a:noFill/>
+          </a:ln>
+        </p:spPr>
+        <p:style>
+          <a:lnRef idx="1">
+            <a:schemeClr val="accent1"/>
+          </a:lnRef>
+          <a:fillRef idx="3">
+            <a:schemeClr val="accent1"/>
+          </a:fillRef>
+          <a:effectRef idx="2">
+            <a:schemeClr val="accent1"/>
+          </a:effectRef>
+          <a:fontRef idx="minor">
+            <a:schemeClr val="lt1"/>
+          </a:fontRef>
+        </p:style>
+        <p:txBody>
+          <a:bodyPr rtlCol="0" anchor="ctr"/>
+          <a:lstStyle/>
+          <a:p>
+            <a:pPr algn="ctr"/>
+          </a:p>
+        </p:txBody>
+      </p:sp>
+      <p:sp>
+        <p:nvSpPr>
+          <p:cNvPr id="5" name="Rectangle 4"/>
+          <p:cNvSpPr/>
+          <p:nvPr/>
+        </p:nvSpPr>
+        <p:spPr>
+          <a:xfrm>
+            <a:off x="0" y="6781800"/>
             <a:ext cx="9144000" cy="76200"/>
           </a:xfrm>
           <a:prstGeom prst="rect">
@@ -3297,16 +3235,19 @@
   <p:clrMapOvr>
     <a:masterClrMapping/>
   </p:clrMapOvr>
+  <p:transition spd="med" dur="603">
+    <p:fade/>
+  </p:transition>
 </p:sld>
 </file>
 
-<file path=ppt/slides/slide3.xml><?xml version="1.0" encoding="utf-8"?>
+<file path=ppt/slides/slide2.xml><?xml version="1.0" encoding="utf-8"?>
 <p:sld xmlns:a="http://schemas.openxmlformats.org/drawingml/2006/main" xmlns:p="http://schemas.openxmlformats.org/presentationml/2006/main" xmlns:r="http://schemas.openxmlformats.org/officeDocument/2006/relationships">
   <p:cSld>
     <p:bg>
       <p:bgPr>
         <a:solidFill>
-          <a:srgbClr val="F5F5F0"/>
+          <a:srgbClr val="ECEAE3"/>
         </a:solidFill>
         <a:effectLst/>
       </p:bgPr>
@@ -3320,6 +3261,49 @@
       <p:grpSpPr/>
       <p:sp>
         <p:nvSpPr>
+          <p:cNvPr id="4" name="Rectangle 3"/>
+          <p:cNvSpPr/>
+          <p:nvPr/>
+        </p:nvSpPr>
+        <p:spPr>
+          <a:xfrm>
+            <a:off x="0" y="0"/>
+            <a:ext cx="9144000" cy="1371600"/>
+          </a:xfrm>
+          <a:prstGeom prst="rect">
+            <a:avLst/>
+          </a:prstGeom>
+          <a:solidFill>
+            <a:srgbClr val="1C2B3A"/>
+          </a:solidFill>
+          <a:ln>
+            <a:noFill/>
+          </a:ln>
+        </p:spPr>
+        <p:style>
+          <a:lnRef idx="1">
+            <a:schemeClr val="accent1"/>
+          </a:lnRef>
+          <a:fillRef idx="3">
+            <a:schemeClr val="accent1"/>
+          </a:fillRef>
+          <a:effectRef idx="2">
+            <a:schemeClr val="accent1"/>
+          </a:effectRef>
+          <a:fontRef idx="minor">
+            <a:schemeClr val="lt1"/>
+          </a:fontRef>
+        </p:style>
+        <p:txBody>
+          <a:bodyPr rtlCol="0" anchor="ctr"/>
+          <a:lstStyle/>
+          <a:p>
+            <a:pPr algn="ctr"/>
+          </a:p>
+        </p:txBody>
+      </p:sp>
+      <p:sp>
+        <p:nvSpPr>
           <p:cNvPr id="2" name="Title 1"/>
           <p:cNvSpPr>
             <a:spLocks noGrp="1"/>
@@ -3334,13 +3318,13 @@
           <a:lstStyle/>
           <a:p>
             <a:r>
-              <a:rPr b="1">
+              <a:rPr sz="3600" b="1">
                 <a:solidFill>
-                  <a:srgbClr val="1C2B3A"/>
+                  <a:srgbClr val="FFFFFF"/>
                 </a:solidFill>
                 <a:latin typeface="Georgia"/>
               </a:rPr>
-              <a:t>Market Analysis</a:t>
+              <a:t>KPI Revenue</a:t>
             </a:r>
           </a:p>
         </p:txBody>
@@ -3361,26 +3345,48 @@
           <a:lstStyle/>
           <a:p>
             <a:r>
-              <a:rPr>
+              <a:rPr sz="1800">
                 <a:solidFill>
                   <a:srgbClr val="1C2B3A"/>
                 </a:solidFill>
                 <a:latin typeface="Trebuchet MS"/>
               </a:rPr>
-              <a:t>Croissance du marché observée sur les 3 derniers trimestres.</a:t>
-            </a:r>
-          </a:p>
-        </p:txBody>
-      </p:sp>
-      <p:sp>
-        <p:nvSpPr>
-          <p:cNvPr id="4" name="Rectangle 3"/>
+              <a:t>— Chiffre d'affaires +15%</a:t>
+            </a:r>
+          </a:p>
+          <a:p>
+            <a:r>
+              <a:rPr sz="1800">
+                <a:solidFill>
+                  <a:srgbClr val="1C2B3A"/>
+                </a:solidFill>
+                <a:latin typeface="Trebuchet MS"/>
+              </a:rPr>
+              <a:t>— ROI amélioré</a:t>
+            </a:r>
+          </a:p>
+          <a:p>
+            <a:r>
+              <a:rPr sz="1800">
+                <a:solidFill>
+                  <a:srgbClr val="1C2B3A"/>
+                </a:solidFill>
+                <a:latin typeface="Trebuchet MS"/>
+              </a:rPr>
+              <a:t>— Budget optimisé</a:t>
+            </a:r>
+          </a:p>
+        </p:txBody>
+      </p:sp>
+      <p:sp>
+        <p:nvSpPr>
+          <p:cNvPr id="5" name="Rectangle 4"/>
           <p:cNvSpPr/>
           <p:nvPr/>
         </p:nvSpPr>
         <p:spPr>
           <a:xfrm>
-            <a:off x="0" y="0"/>
+            <a:off x="0" y="6781800"/>
             <a:ext cx="9144000" cy="76200"/>
           </a:xfrm>
           <a:prstGeom prst="rect">
@@ -3423,13 +3429,13 @@
 </p:sld>
 </file>
 
-<file path=ppt/slides/slide4.xml><?xml version="1.0" encoding="utf-8"?>
+<file path=ppt/slides/slide3.xml><?xml version="1.0" encoding="utf-8"?>
 <p:sld xmlns:a="http://schemas.openxmlformats.org/drawingml/2006/main" xmlns:p="http://schemas.openxmlformats.org/presentationml/2006/main" xmlns:r="http://schemas.openxmlformats.org/officeDocument/2006/relationships">
   <p:cSld>
     <p:bg>
       <p:bgPr>
         <a:solidFill>
-          <a:srgbClr val="ECEAE3"/>
+          <a:srgbClr val="F5F5F0"/>
         </a:solidFill>
         <a:effectLst/>
       </p:bgPr>
@@ -3443,6 +3449,49 @@
       <p:grpSpPr/>
       <p:sp>
         <p:nvSpPr>
+          <p:cNvPr id="4" name="Rectangle 3"/>
+          <p:cNvSpPr/>
+          <p:nvPr/>
+        </p:nvSpPr>
+        <p:spPr>
+          <a:xfrm>
+            <a:off x="0" y="0"/>
+            <a:ext cx="9144000" cy="1371600"/>
+          </a:xfrm>
+          <a:prstGeom prst="rect">
+            <a:avLst/>
+          </a:prstGeom>
+          <a:solidFill>
+            <a:srgbClr val="1C2B3A"/>
+          </a:solidFill>
+          <a:ln>
+            <a:noFill/>
+          </a:ln>
+        </p:spPr>
+        <p:style>
+          <a:lnRef idx="1">
+            <a:schemeClr val="accent1"/>
+          </a:lnRef>
+          <a:fillRef idx="3">
+            <a:schemeClr val="accent1"/>
+          </a:fillRef>
+          <a:effectRef idx="2">
+            <a:schemeClr val="accent1"/>
+          </a:effectRef>
+          <a:fontRef idx="minor">
+            <a:schemeClr val="lt1"/>
+          </a:fontRef>
+        </p:style>
+        <p:txBody>
+          <a:bodyPr rtlCol="0" anchor="ctr"/>
+          <a:lstStyle/>
+          <a:p>
+            <a:pPr algn="ctr"/>
+          </a:p>
+        </p:txBody>
+      </p:sp>
+      <p:sp>
+        <p:nvSpPr>
           <p:cNvPr id="2" name="Title 1"/>
           <p:cNvSpPr>
             <a:spLocks noGrp="1"/>
@@ -3457,13 +3506,13 @@
           <a:lstStyle/>
           <a:p>
             <a:r>
-              <a:rPr b="1">
+              <a:rPr sz="3600" b="1">
                 <a:solidFill>
-                  <a:srgbClr val="1C2B3A"/>
+                  <a:srgbClr val="FFFFFF"/>
                 </a:solidFill>
                 <a:latin typeface="Georgia"/>
               </a:rPr>
-              <a:t>Roadmap</a:t>
+              <a:t>Market Analysis</a:t>
             </a:r>
           </a:p>
         </p:txBody>
@@ -3484,48 +3533,26 @@
           <a:lstStyle/>
           <a:p>
             <a:r>
-              <a:rPr>
+              <a:rPr sz="1800">
                 <a:solidFill>
                   <a:srgbClr val="1C2B3A"/>
                 </a:solidFill>
                 <a:latin typeface="Trebuchet MS"/>
               </a:rPr>
-              <a:t>— Phase 1 : Q1</a:t>
-            </a:r>
-          </a:p>
-          <a:p>
-            <a:r>
-              <a:rPr>
-                <a:solidFill>
-                  <a:srgbClr val="1C2B3A"/>
-                </a:solidFill>
-                <a:latin typeface="Trebuchet MS"/>
-              </a:rPr>
-              <a:t>— Phase 2 : Q2</a:t>
-            </a:r>
-          </a:p>
-          <a:p>
-            <a:r>
-              <a:rPr>
-                <a:solidFill>
-                  <a:srgbClr val="1C2B3A"/>
-                </a:solidFill>
-                <a:latin typeface="Trebuchet MS"/>
-              </a:rPr>
-              <a:t>— Phase 3 : Q3</a:t>
-            </a:r>
-          </a:p>
-        </p:txBody>
-      </p:sp>
-      <p:sp>
-        <p:nvSpPr>
-          <p:cNvPr id="4" name="Rectangle 3"/>
+              <a:t>Croissance du marché observée sur les 3 derniers trimestres.</a:t>
+            </a:r>
+          </a:p>
+        </p:txBody>
+      </p:sp>
+      <p:sp>
+        <p:nvSpPr>
+          <p:cNvPr id="5" name="Rectangle 4"/>
           <p:cNvSpPr/>
           <p:nvPr/>
         </p:nvSpPr>
         <p:spPr>
           <a:xfrm>
-            <a:off x="0" y="0"/>
+            <a:off x="0" y="6781800"/>
             <a:ext cx="9144000" cy="76200"/>
           </a:xfrm>
           <a:prstGeom prst="rect">
@@ -3565,19 +3592,19 @@
   <p:clrMapOvr>
     <a:masterClrMapping/>
   </p:clrMapOvr>
-  <p:transition spd="med" dur="672">
+  <p:transition spd="med" dur="583">
     <p:fade/>
   </p:transition>
 </p:sld>
 </file>
 
-<file path=ppt/slides/slide5.xml><?xml version="1.0" encoding="utf-8"?>
+<file path=ppt/slides/slide4.xml><?xml version="1.0" encoding="utf-8"?>
 <p:sld xmlns:a="http://schemas.openxmlformats.org/drawingml/2006/main" xmlns:p="http://schemas.openxmlformats.org/presentationml/2006/main" xmlns:r="http://schemas.openxmlformats.org/officeDocument/2006/relationships">
   <p:cSld>
     <p:bg>
       <p:bgPr>
         <a:solidFill>
-          <a:srgbClr val="1C2B3A"/>
+          <a:srgbClr val="ECEAE3"/>
         </a:solidFill>
         <a:effectLst/>
       </p:bgPr>
@@ -3591,57 +3618,132 @@
       <p:grpSpPr/>
       <p:sp>
         <p:nvSpPr>
+          <p:cNvPr id="4" name="Rectangle 3"/>
+          <p:cNvSpPr/>
+          <p:nvPr/>
+        </p:nvSpPr>
+        <p:spPr>
+          <a:xfrm>
+            <a:off x="0" y="0"/>
+            <a:ext cx="9144000" cy="1371600"/>
+          </a:xfrm>
+          <a:prstGeom prst="rect">
+            <a:avLst/>
+          </a:prstGeom>
+          <a:solidFill>
+            <a:srgbClr val="1C2B3A"/>
+          </a:solidFill>
+          <a:ln>
+            <a:noFill/>
+          </a:ln>
+        </p:spPr>
+        <p:style>
+          <a:lnRef idx="1">
+            <a:schemeClr val="accent1"/>
+          </a:lnRef>
+          <a:fillRef idx="3">
+            <a:schemeClr val="accent1"/>
+          </a:fillRef>
+          <a:effectRef idx="2">
+            <a:schemeClr val="accent1"/>
+          </a:effectRef>
+          <a:fontRef idx="minor">
+            <a:schemeClr val="lt1"/>
+          </a:fontRef>
+        </p:style>
+        <p:txBody>
+          <a:bodyPr rtlCol="0" anchor="ctr"/>
+          <a:lstStyle/>
+          <a:p>
+            <a:pPr algn="ctr"/>
+          </a:p>
+        </p:txBody>
+      </p:sp>
+      <p:sp>
+        <p:nvSpPr>
           <p:cNvPr id="2" name="Title 1"/>
           <p:cNvSpPr>
             <a:spLocks noGrp="1"/>
           </p:cNvSpPr>
           <p:nvPr>
-            <p:ph type="ctrTitle"/>
-          </p:nvPr>
-        </p:nvSpPr>
-        <p:spPr/>
-        <p:txBody>
-          <a:bodyPr/>
-          <a:lstStyle/>
-          <a:p>
-            <a:r>
-              <a:rPr b="1">
+            <p:ph type="title"/>
+          </p:nvPr>
+        </p:nvSpPr>
+        <p:spPr/>
+        <p:txBody>
+          <a:bodyPr/>
+          <a:lstStyle/>
+          <a:p>
+            <a:r>
+              <a:rPr sz="3600" b="1">
                 <a:solidFill>
-                  <a:srgbClr val="C8A84B"/>
+                  <a:srgbClr val="FFFFFF"/>
                 </a:solidFill>
                 <a:latin typeface="Georgia"/>
               </a:rPr>
-              <a:t>Merci</a:t>
-            </a:r>
-          </a:p>
-        </p:txBody>
-      </p:sp>
-      <p:sp>
-        <p:nvSpPr>
-          <p:cNvPr id="3" name="Subtitle 2"/>
-          <p:cNvSpPr>
-            <a:spLocks noGrp="1"/>
-          </p:cNvSpPr>
-          <p:nvPr>
-            <p:ph type="subTitle" idx="1"/>
-          </p:nvPr>
-        </p:nvSpPr>
-        <p:spPr/>
-        <p:txBody>
-          <a:bodyPr/>
-          <a:lstStyle/>
-          <a:p/>
-        </p:txBody>
-      </p:sp>
-      <p:sp>
-        <p:nvSpPr>
-          <p:cNvPr id="4" name="Rectangle 3"/>
+              <a:t>Roadmap</a:t>
+            </a:r>
+          </a:p>
+        </p:txBody>
+      </p:sp>
+      <p:sp>
+        <p:nvSpPr>
+          <p:cNvPr id="3" name="Content Placeholder 2"/>
+          <p:cNvSpPr>
+            <a:spLocks noGrp="1"/>
+          </p:cNvSpPr>
+          <p:nvPr>
+            <p:ph idx="1"/>
+          </p:nvPr>
+        </p:nvSpPr>
+        <p:spPr/>
+        <p:txBody>
+          <a:bodyPr/>
+          <a:lstStyle/>
+          <a:p>
+            <a:r>
+              <a:rPr sz="1800">
+                <a:solidFill>
+                  <a:srgbClr val="1C2B3A"/>
+                </a:solidFill>
+                <a:latin typeface="Trebuchet MS"/>
+              </a:rPr>
+              <a:t>— Phase 1 : Q1</a:t>
+            </a:r>
+          </a:p>
+          <a:p>
+            <a:r>
+              <a:rPr sz="1800">
+                <a:solidFill>
+                  <a:srgbClr val="1C2B3A"/>
+                </a:solidFill>
+                <a:latin typeface="Trebuchet MS"/>
+              </a:rPr>
+              <a:t>— Phase 2 : Q2</a:t>
+            </a:r>
+          </a:p>
+          <a:p>
+            <a:r>
+              <a:rPr sz="1800">
+                <a:solidFill>
+                  <a:srgbClr val="1C2B3A"/>
+                </a:solidFill>
+                <a:latin typeface="Trebuchet MS"/>
+              </a:rPr>
+              <a:t>— Phase 3 : Q3</a:t>
+            </a:r>
+          </a:p>
+        </p:txBody>
+      </p:sp>
+      <p:sp>
+        <p:nvSpPr>
+          <p:cNvPr id="5" name="Rectangle 4"/>
           <p:cNvSpPr/>
           <p:nvPr/>
         </p:nvSpPr>
         <p:spPr>
           <a:xfrm>
-            <a:off x="0" y="0"/>
+            <a:off x="0" y="6781800"/>
             <a:ext cx="9144000" cy="76200"/>
           </a:xfrm>
           <a:prstGeom prst="rect">
@@ -3681,7 +3783,163 @@
   <p:clrMapOvr>
     <a:masterClrMapping/>
   </p:clrMapOvr>
-  <p:transition spd="med" dur="662">
+</p:sld>
+</file>
+
+<file path=ppt/slides/slide5.xml><?xml version="1.0" encoding="utf-8"?>
+<p:sld xmlns:a="http://schemas.openxmlformats.org/drawingml/2006/main" xmlns:p="http://schemas.openxmlformats.org/presentationml/2006/main" xmlns:r="http://schemas.openxmlformats.org/officeDocument/2006/relationships">
+  <p:cSld>
+    <p:bg>
+      <p:bgPr>
+        <a:solidFill>
+          <a:srgbClr val="1C2B3A"/>
+        </a:solidFill>
+        <a:effectLst/>
+      </p:bgPr>
+    </p:bg>
+    <p:spTree>
+      <p:nvGrpSpPr>
+        <p:cNvPr id="1" name=""/>
+        <p:cNvGrpSpPr/>
+        <p:nvPr/>
+      </p:nvGrpSpPr>
+      <p:grpSpPr/>
+      <p:sp>
+        <p:nvSpPr>
+          <p:cNvPr id="2" name="Title 1"/>
+          <p:cNvSpPr>
+            <a:spLocks noGrp="1"/>
+          </p:cNvSpPr>
+          <p:nvPr>
+            <p:ph type="ctrTitle"/>
+          </p:nvPr>
+        </p:nvSpPr>
+        <p:spPr/>
+        <p:txBody>
+          <a:bodyPr/>
+          <a:lstStyle/>
+          <a:p>
+            <a:r>
+              <a:rPr sz="5200" b="1">
+                <a:solidFill>
+                  <a:srgbClr val="C8A84B"/>
+                </a:solidFill>
+                <a:latin typeface="Georgia"/>
+              </a:rPr>
+              <a:t>Merci</a:t>
+            </a:r>
+          </a:p>
+        </p:txBody>
+      </p:sp>
+      <p:sp>
+        <p:nvSpPr>
+          <p:cNvPr id="3" name="Subtitle 2"/>
+          <p:cNvSpPr>
+            <a:spLocks noGrp="1"/>
+          </p:cNvSpPr>
+          <p:nvPr>
+            <p:ph type="subTitle" idx="1"/>
+          </p:nvPr>
+        </p:nvSpPr>
+        <p:spPr/>
+        <p:txBody>
+          <a:bodyPr/>
+          <a:lstStyle/>
+          <a:p/>
+        </p:txBody>
+      </p:sp>
+      <p:sp>
+        <p:nvSpPr>
+          <p:cNvPr id="4" name="Rectangle 3"/>
+          <p:cNvSpPr/>
+          <p:nvPr/>
+        </p:nvSpPr>
+        <p:spPr>
+          <a:xfrm>
+            <a:off x="0" y="0"/>
+            <a:ext cx="109728" cy="6858000"/>
+          </a:xfrm>
+          <a:prstGeom prst="rect">
+            <a:avLst/>
+          </a:prstGeom>
+          <a:solidFill>
+            <a:srgbClr val="C8A84B"/>
+          </a:solidFill>
+          <a:ln>
+            <a:noFill/>
+          </a:ln>
+        </p:spPr>
+        <p:style>
+          <a:lnRef idx="1">
+            <a:schemeClr val="accent1"/>
+          </a:lnRef>
+          <a:fillRef idx="3">
+            <a:schemeClr val="accent1"/>
+          </a:fillRef>
+          <a:effectRef idx="2">
+            <a:schemeClr val="accent1"/>
+          </a:effectRef>
+          <a:fontRef idx="minor">
+            <a:schemeClr val="lt1"/>
+          </a:fontRef>
+        </p:style>
+        <p:txBody>
+          <a:bodyPr rtlCol="0" anchor="ctr"/>
+          <a:lstStyle/>
+          <a:p>
+            <a:pPr algn="ctr"/>
+          </a:p>
+        </p:txBody>
+      </p:sp>
+      <p:sp>
+        <p:nvSpPr>
+          <p:cNvPr id="5" name="Rectangle 4"/>
+          <p:cNvSpPr/>
+          <p:nvPr/>
+        </p:nvSpPr>
+        <p:spPr>
+          <a:xfrm>
+            <a:off x="0" y="6781800"/>
+            <a:ext cx="9144000" cy="76200"/>
+          </a:xfrm>
+          <a:prstGeom prst="rect">
+            <a:avLst/>
+          </a:prstGeom>
+          <a:solidFill>
+            <a:srgbClr val="C8A84B"/>
+          </a:solidFill>
+          <a:ln>
+            <a:noFill/>
+          </a:ln>
+        </p:spPr>
+        <p:style>
+          <a:lnRef idx="1">
+            <a:schemeClr val="accent1"/>
+          </a:lnRef>
+          <a:fillRef idx="3">
+            <a:schemeClr val="accent1"/>
+          </a:fillRef>
+          <a:effectRef idx="2">
+            <a:schemeClr val="accent1"/>
+          </a:effectRef>
+          <a:fontRef idx="minor">
+            <a:schemeClr val="lt1"/>
+          </a:fontRef>
+        </p:style>
+        <p:txBody>
+          <a:bodyPr rtlCol="0" anchor="ctr"/>
+          <a:lstStyle/>
+          <a:p>
+            <a:pPr algn="ctr"/>
+          </a:p>
+        </p:txBody>
+      </p:sp>
+    </p:spTree>
+  </p:cSld>
+  <p:clrMapOvr>
+    <a:masterClrMapping/>
+  </p:clrMapOvr>
+  <p:transition spd="med" dur="668">
     <p:fade/>
   </p:transition>
 </p:sld>

</xml_diff>

<commit_message>
feat: rebuild presentations from scratch instead of modifying in place
Complete rewrite of the transformation pipeline:
- extract() reads all text content from the source .pptx (titles, body lines,
  notes) without keeping any formatting
- build_presentation() creates a brand new Presentation() from a blank layout,
  placing every text box and decorative shape from scratch
- Layout system: title band (top 21%), two-column body for 4+ lines,
  vertical accent strips, bottom rules, section number badges
- Each slide type (title/section/content/closing) has its own layout function
- No dependency on original shapes, positions, or styles

https://claude.ai/code/session_01Ku7J1XKnJyhda2UCdNL7n9
</commit_message>
<xml_diff>
--- a/input/test_corporate_redesigned.pptx
+++ b/input/test_corporate_redesigned.pptx
@@ -3102,58 +3102,14 @@
       <p:grpSpPr/>
       <p:sp>
         <p:nvSpPr>
-          <p:cNvPr id="2" name="Title 1"/>
-          <p:cNvSpPr>
-            <a:spLocks noGrp="1"/>
-          </p:cNvSpPr>
-          <p:nvPr>
-            <p:ph type="ctrTitle"/>
-          </p:nvPr>
-        </p:nvSpPr>
-        <p:spPr/>
-        <p:txBody>
-          <a:bodyPr/>
-          <a:lstStyle/>
-          <a:p>
-            <a:r>
-              <a:rPr sz="5200" b="1">
-                <a:solidFill>
-                  <a:srgbClr val="C8A84B"/>
-                </a:solidFill>
-                <a:latin typeface="Georgia"/>
-              </a:rPr>
-              <a:t>Stratégie Q3 2025</a:t>
-            </a:r>
-          </a:p>
-        </p:txBody>
-      </p:sp>
-      <p:sp>
-        <p:nvSpPr>
-          <p:cNvPr id="3" name="Subtitle 2"/>
-          <p:cNvSpPr>
-            <a:spLocks noGrp="1"/>
-          </p:cNvSpPr>
-          <p:nvPr>
-            <p:ph type="subTitle" idx="1"/>
-          </p:nvPr>
-        </p:nvSpPr>
-        <p:spPr/>
-        <p:txBody>
-          <a:bodyPr/>
-          <a:lstStyle/>
-          <a:p/>
-        </p:txBody>
-      </p:sp>
-      <p:sp>
-        <p:nvSpPr>
-          <p:cNvPr id="4" name="Rectangle 3"/>
+          <p:cNvPr id="2" name="Rectangle 1"/>
           <p:cNvSpPr/>
           <p:nvPr/>
         </p:nvSpPr>
         <p:spPr>
           <a:xfrm>
             <a:off x="0" y="0"/>
-            <a:ext cx="109728" cy="6858000"/>
+            <a:ext cx="64008" cy="6858000"/>
           </a:xfrm>
           <a:prstGeom prst="rect">
             <a:avLst/>
@@ -3189,14 +3145,14 @@
       </p:sp>
       <p:sp>
         <p:nvSpPr>
-          <p:cNvPr id="5" name="Rectangle 4"/>
+          <p:cNvPr id="3" name="Rectangle 2"/>
           <p:cNvSpPr/>
           <p:nvPr/>
         </p:nvSpPr>
         <p:spPr>
           <a:xfrm>
-            <a:off x="0" y="6781800"/>
-            <a:ext cx="9144000" cy="76200"/>
+            <a:off x="0" y="6705600"/>
+            <a:ext cx="9144000" cy="152400"/>
           </a:xfrm>
           <a:prstGeom prst="rect">
             <a:avLst/>
@@ -3230,35 +3186,6 @@
           </a:p>
         </p:txBody>
       </p:sp>
-    </p:spTree>
-  </p:cSld>
-  <p:clrMapOvr>
-    <a:masterClrMapping/>
-  </p:clrMapOvr>
-  <p:transition spd="med" dur="603">
-    <p:fade/>
-  </p:transition>
-</p:sld>
-</file>
-
-<file path=ppt/slides/slide2.xml><?xml version="1.0" encoding="utf-8"?>
-<p:sld xmlns:a="http://schemas.openxmlformats.org/drawingml/2006/main" xmlns:p="http://schemas.openxmlformats.org/presentationml/2006/main" xmlns:r="http://schemas.openxmlformats.org/officeDocument/2006/relationships">
-  <p:cSld>
-    <p:bg>
-      <p:bgPr>
-        <a:solidFill>
-          <a:srgbClr val="ECEAE3"/>
-        </a:solidFill>
-        <a:effectLst/>
-      </p:bgPr>
-    </p:bg>
-    <p:spTree>
-      <p:nvGrpSpPr>
-        <p:cNvPr id="1" name=""/>
-        <p:cNvGrpSpPr/>
-        <p:nvPr/>
-      </p:nvGrpSpPr>
-      <p:grpSpPr/>
       <p:sp>
         <p:nvSpPr>
           <p:cNvPr id="4" name="Rectangle 3"/>
@@ -3267,14 +3194,14 @@
         </p:nvSpPr>
         <p:spPr>
           <a:xfrm>
-            <a:off x="0" y="0"/>
-            <a:ext cx="9144000" cy="1371600"/>
+            <a:off x="841248" y="2880360"/>
+            <a:ext cx="4114800" cy="152400"/>
           </a:xfrm>
           <a:prstGeom prst="rect">
             <a:avLst/>
           </a:prstGeom>
           <a:solidFill>
-            <a:srgbClr val="1C2B3A"/>
+            <a:srgbClr val="C8A84B"/>
           </a:solidFill>
           <a:ln>
             <a:noFill/>
@@ -3304,90 +3231,76 @@
       </p:sp>
       <p:sp>
         <p:nvSpPr>
-          <p:cNvPr id="2" name="Title 1"/>
-          <p:cNvSpPr>
-            <a:spLocks noGrp="1"/>
-          </p:cNvSpPr>
-          <p:nvPr>
-            <p:ph type="title"/>
-          </p:nvPr>
-        </p:nvSpPr>
-        <p:spPr/>
-        <p:txBody>
-          <a:bodyPr/>
-          <a:lstStyle/>
-          <a:p>
-            <a:r>
-              <a:rPr sz="3600" b="1">
+          <p:cNvPr id="5" name="TextBox 4"/>
+          <p:cNvSpPr txBox="1"/>
+          <p:nvPr/>
+        </p:nvSpPr>
+        <p:spPr>
+          <a:xfrm>
+            <a:off x="978408" y="3169920"/>
+            <a:ext cx="7571232" cy="2011680"/>
+          </a:xfrm>
+          <a:prstGeom prst="rect">
+            <a:avLst/>
+          </a:prstGeom>
+          <a:noFill/>
+        </p:spPr>
+        <p:txBody>
+          <a:bodyPr wrap="square"/>
+          <a:lstStyle/>
+          <a:p>
+            <a:pPr algn="l"/>
+            <a:r>
+              <a:rPr sz="4800" b="1" i="0">
                 <a:solidFill>
-                  <a:srgbClr val="FFFFFF"/>
+                  <a:srgbClr val="C8A84B"/>
                 </a:solidFill>
                 <a:latin typeface="Georgia"/>
               </a:rPr>
-              <a:t>KPI Revenue</a:t>
-            </a:r>
-          </a:p>
-        </p:txBody>
-      </p:sp>
-      <p:sp>
-        <p:nvSpPr>
-          <p:cNvPr id="3" name="Content Placeholder 2"/>
-          <p:cNvSpPr>
-            <a:spLocks noGrp="1"/>
-          </p:cNvSpPr>
-          <p:nvPr>
-            <p:ph idx="1"/>
-          </p:nvPr>
-        </p:nvSpPr>
-        <p:spPr/>
-        <p:txBody>
-          <a:bodyPr/>
-          <a:lstStyle/>
-          <a:p>
-            <a:r>
-              <a:rPr sz="1800">
-                <a:solidFill>
-                  <a:srgbClr val="1C2B3A"/>
-                </a:solidFill>
-                <a:latin typeface="Trebuchet MS"/>
-              </a:rPr>
-              <a:t>— Chiffre d'affaires +15%</a:t>
-            </a:r>
-          </a:p>
-          <a:p>
-            <a:r>
-              <a:rPr sz="1800">
-                <a:solidFill>
-                  <a:srgbClr val="1C2B3A"/>
-                </a:solidFill>
-                <a:latin typeface="Trebuchet MS"/>
-              </a:rPr>
-              <a:t>— ROI amélioré</a:t>
-            </a:r>
-          </a:p>
-          <a:p>
-            <a:r>
-              <a:rPr sz="1800">
-                <a:solidFill>
-                  <a:srgbClr val="1C2B3A"/>
-                </a:solidFill>
-                <a:latin typeface="Trebuchet MS"/>
-              </a:rPr>
-              <a:t>— Budget optimisé</a:t>
-            </a:r>
-          </a:p>
-        </p:txBody>
-      </p:sp>
-      <p:sp>
-        <p:nvSpPr>
-          <p:cNvPr id="5" name="Rectangle 4"/>
+              <a:t>Stratégie Q3 2025</a:t>
+            </a:r>
+          </a:p>
+        </p:txBody>
+      </p:sp>
+    </p:spTree>
+  </p:cSld>
+  <p:clrMapOvr>
+    <a:masterClrMapping/>
+  </p:clrMapOvr>
+  <p:transition spd="med" dur="633">
+    <p:fade/>
+  </p:transition>
+</p:sld>
+</file>
+
+<file path=ppt/slides/slide2.xml><?xml version="1.0" encoding="utf-8"?>
+<p:sld xmlns:a="http://schemas.openxmlformats.org/drawingml/2006/main" xmlns:p="http://schemas.openxmlformats.org/presentationml/2006/main" xmlns:r="http://schemas.openxmlformats.org/officeDocument/2006/relationships">
+  <p:cSld>
+    <p:bg>
+      <p:bgPr>
+        <a:solidFill>
+          <a:srgbClr val="1C2B3A"/>
+        </a:solidFill>
+        <a:effectLst/>
+      </p:bgPr>
+    </p:bg>
+    <p:spTree>
+      <p:nvGrpSpPr>
+        <p:cNvPr id="1" name=""/>
+        <p:cNvGrpSpPr/>
+        <p:nvPr/>
+      </p:nvGrpSpPr>
+      <p:grpSpPr/>
+      <p:sp>
+        <p:nvSpPr>
+          <p:cNvPr id="2" name="Rectangle 1"/>
           <p:cNvSpPr/>
           <p:nvPr/>
         </p:nvSpPr>
         <p:spPr>
           <a:xfrm>
-            <a:off x="0" y="6781800"/>
-            <a:ext cx="9144000" cy="76200"/>
+            <a:off x="0" y="5623560"/>
+            <a:ext cx="9144000" cy="1234440"/>
           </a:xfrm>
           <a:prstGeom prst="rect">
             <a:avLst/>
@@ -3421,48 +3334,22 @@
           </a:p>
         </p:txBody>
       </p:sp>
-    </p:spTree>
-  </p:cSld>
-  <p:clrMapOvr>
-    <a:masterClrMapping/>
-  </p:clrMapOvr>
-</p:sld>
-</file>
-
-<file path=ppt/slides/slide3.xml><?xml version="1.0" encoding="utf-8"?>
-<p:sld xmlns:a="http://schemas.openxmlformats.org/drawingml/2006/main" xmlns:p="http://schemas.openxmlformats.org/presentationml/2006/main" xmlns:r="http://schemas.openxmlformats.org/officeDocument/2006/relationships">
-  <p:cSld>
-    <p:bg>
-      <p:bgPr>
-        <a:solidFill>
-          <a:srgbClr val="F5F5F0"/>
-        </a:solidFill>
-        <a:effectLst/>
-      </p:bgPr>
-    </p:bg>
-    <p:spTree>
-      <p:nvGrpSpPr>
-        <p:cNvPr id="1" name=""/>
-        <p:cNvGrpSpPr/>
-        <p:nvPr/>
-      </p:nvGrpSpPr>
-      <p:grpSpPr/>
-      <p:sp>
-        <p:nvSpPr>
-          <p:cNvPr id="4" name="Rectangle 3"/>
+      <p:sp>
+        <p:nvSpPr>
+          <p:cNvPr id="3" name="Rectangle 2"/>
           <p:cNvSpPr/>
           <p:nvPr/>
         </p:nvSpPr>
         <p:spPr>
           <a:xfrm>
-            <a:off x="0" y="0"/>
-            <a:ext cx="9144000" cy="1371600"/>
+            <a:off x="594360" y="1714500"/>
+            <a:ext cx="502920" cy="502920"/>
           </a:xfrm>
           <a:prstGeom prst="rect">
             <a:avLst/>
           </a:prstGeom>
           <a:solidFill>
-            <a:srgbClr val="1C2B3A"/>
+            <a:srgbClr val="C8A84B"/>
           </a:solidFill>
           <a:ln>
             <a:noFill/>
@@ -3492,68 +3379,142 @@
       </p:sp>
       <p:sp>
         <p:nvSpPr>
-          <p:cNvPr id="2" name="Title 1"/>
-          <p:cNvSpPr>
-            <a:spLocks noGrp="1"/>
-          </p:cNvSpPr>
-          <p:nvPr>
-            <p:ph type="title"/>
-          </p:nvPr>
-        </p:nvSpPr>
-        <p:spPr/>
-        <p:txBody>
-          <a:bodyPr/>
-          <a:lstStyle/>
-          <a:p>
-            <a:r>
-              <a:rPr sz="3600" b="1">
+          <p:cNvPr id="4" name="TextBox 3"/>
+          <p:cNvSpPr txBox="1"/>
+          <p:nvPr/>
+        </p:nvSpPr>
+        <p:spPr>
+          <a:xfrm>
+            <a:off x="594360" y="1714500"/>
+            <a:ext cx="502920" cy="502920"/>
+          </a:xfrm>
+          <a:prstGeom prst="rect">
+            <a:avLst/>
+          </a:prstGeom>
+          <a:noFill/>
+        </p:spPr>
+        <p:txBody>
+          <a:bodyPr wrap="square"/>
+          <a:lstStyle/>
+          <a:p>
+            <a:pPr algn="ctr"/>
+            <a:r>
+              <a:rPr sz="2600" b="1" i="0">
+                <a:solidFill>
+                  <a:srgbClr val="1C2B3A"/>
+                </a:solidFill>
+                <a:latin typeface="Georgia"/>
+              </a:rPr>
+              <a:t>1</a:t>
+            </a:r>
+          </a:p>
+        </p:txBody>
+      </p:sp>
+      <p:sp>
+        <p:nvSpPr>
+          <p:cNvPr id="5" name="TextBox 4"/>
+          <p:cNvSpPr txBox="1"/>
+          <p:nvPr/>
+        </p:nvSpPr>
+        <p:spPr>
+          <a:xfrm>
+            <a:off x="1371600" y="1508760"/>
+            <a:ext cx="7178040" cy="1463040"/>
+          </a:xfrm>
+          <a:prstGeom prst="rect">
+            <a:avLst/>
+          </a:prstGeom>
+          <a:noFill/>
+        </p:spPr>
+        <p:txBody>
+          <a:bodyPr wrap="square"/>
+          <a:lstStyle/>
+          <a:p>
+            <a:pPr algn="l"/>
+            <a:r>
+              <a:rPr sz="4400" b="1" i="0">
+                <a:solidFill>
+                  <a:srgbClr val="C8A84B"/>
+                </a:solidFill>
+                <a:latin typeface="Georgia"/>
+              </a:rPr>
+              <a:t>KPI Revenue</a:t>
+            </a:r>
+          </a:p>
+        </p:txBody>
+      </p:sp>
+      <p:sp>
+        <p:nvSpPr>
+          <p:cNvPr id="6" name="TextBox 5"/>
+          <p:cNvSpPr txBox="1"/>
+          <p:nvPr/>
+        </p:nvSpPr>
+        <p:spPr>
+          <a:xfrm>
+            <a:off x="594360" y="4251960"/>
+            <a:ext cx="7955280" cy="822960"/>
+          </a:xfrm>
+          <a:prstGeom prst="rect">
+            <a:avLst/>
+          </a:prstGeom>
+          <a:noFill/>
+        </p:spPr>
+        <p:txBody>
+          <a:bodyPr wrap="square"/>
+          <a:lstStyle/>
+          <a:p>
+            <a:pPr algn="l"/>
+            <a:r>
+              <a:rPr sz="2000" b="0" i="1">
                 <a:solidFill>
                   <a:srgbClr val="FFFFFF"/>
                 </a:solidFill>
-                <a:latin typeface="Georgia"/>
-              </a:rPr>
-              <a:t>Market Analysis</a:t>
-            </a:r>
-          </a:p>
-        </p:txBody>
-      </p:sp>
-      <p:sp>
-        <p:nvSpPr>
-          <p:cNvPr id="3" name="Content Placeholder 2"/>
-          <p:cNvSpPr>
-            <a:spLocks noGrp="1"/>
-          </p:cNvSpPr>
-          <p:nvPr>
-            <p:ph idx="1"/>
-          </p:nvPr>
-        </p:nvSpPr>
-        <p:spPr/>
-        <p:txBody>
-          <a:bodyPr/>
-          <a:lstStyle/>
-          <a:p>
-            <a:r>
-              <a:rPr sz="1800">
-                <a:solidFill>
-                  <a:srgbClr val="1C2B3A"/>
-                </a:solidFill>
                 <a:latin typeface="Trebuchet MS"/>
               </a:rPr>
-              <a:t>Croissance du marché observée sur les 3 derniers trimestres.</a:t>
-            </a:r>
-          </a:p>
-        </p:txBody>
-      </p:sp>
-      <p:sp>
-        <p:nvSpPr>
-          <p:cNvPr id="5" name="Rectangle 4"/>
+              <a:t>• Chiffre d'affaires +15%</a:t>
+            </a:r>
+          </a:p>
+        </p:txBody>
+      </p:sp>
+    </p:spTree>
+  </p:cSld>
+  <p:clrMapOvr>
+    <a:masterClrMapping/>
+  </p:clrMapOvr>
+  <p:transition spd="med" dur="552">
+    <p:fade/>
+  </p:transition>
+</p:sld>
+</file>
+
+<file path=ppt/slides/slide3.xml><?xml version="1.0" encoding="utf-8"?>
+<p:sld xmlns:a="http://schemas.openxmlformats.org/drawingml/2006/main" xmlns:p="http://schemas.openxmlformats.org/presentationml/2006/main" xmlns:r="http://schemas.openxmlformats.org/officeDocument/2006/relationships">
+  <p:cSld>
+    <p:bg>
+      <p:bgPr>
+        <a:solidFill>
+          <a:srgbClr val="1C2B3A"/>
+        </a:solidFill>
+        <a:effectLst/>
+      </p:bgPr>
+    </p:bg>
+    <p:spTree>
+      <p:nvGrpSpPr>
+        <p:cNvPr id="1" name=""/>
+        <p:cNvGrpSpPr/>
+        <p:nvPr/>
+      </p:nvGrpSpPr>
+      <p:grpSpPr/>
+      <p:sp>
+        <p:nvSpPr>
+          <p:cNvPr id="2" name="Rectangle 1"/>
           <p:cNvSpPr/>
           <p:nvPr/>
         </p:nvSpPr>
         <p:spPr>
           <a:xfrm>
-            <a:off x="0" y="6781800"/>
-            <a:ext cx="9144000" cy="76200"/>
+            <a:off x="0" y="5623560"/>
+            <a:ext cx="9144000" cy="1234440"/>
           </a:xfrm>
           <a:prstGeom prst="rect">
             <a:avLst/>
@@ -3587,51 +3548,22 @@
           </a:p>
         </p:txBody>
       </p:sp>
-    </p:spTree>
-  </p:cSld>
-  <p:clrMapOvr>
-    <a:masterClrMapping/>
-  </p:clrMapOvr>
-  <p:transition spd="med" dur="583">
-    <p:fade/>
-  </p:transition>
-</p:sld>
-</file>
-
-<file path=ppt/slides/slide4.xml><?xml version="1.0" encoding="utf-8"?>
-<p:sld xmlns:a="http://schemas.openxmlformats.org/drawingml/2006/main" xmlns:p="http://schemas.openxmlformats.org/presentationml/2006/main" xmlns:r="http://schemas.openxmlformats.org/officeDocument/2006/relationships">
-  <p:cSld>
-    <p:bg>
-      <p:bgPr>
-        <a:solidFill>
-          <a:srgbClr val="ECEAE3"/>
-        </a:solidFill>
-        <a:effectLst/>
-      </p:bgPr>
-    </p:bg>
-    <p:spTree>
-      <p:nvGrpSpPr>
-        <p:cNvPr id="1" name=""/>
-        <p:cNvGrpSpPr/>
-        <p:nvPr/>
-      </p:nvGrpSpPr>
-      <p:grpSpPr/>
-      <p:sp>
-        <p:nvSpPr>
-          <p:cNvPr id="4" name="Rectangle 3"/>
+      <p:sp>
+        <p:nvSpPr>
+          <p:cNvPr id="3" name="Rectangle 2"/>
           <p:cNvSpPr/>
           <p:nvPr/>
         </p:nvSpPr>
         <p:spPr>
           <a:xfrm>
-            <a:off x="0" y="0"/>
-            <a:ext cx="9144000" cy="1371600"/>
+            <a:off x="594360" y="1714500"/>
+            <a:ext cx="502920" cy="502920"/>
           </a:xfrm>
           <a:prstGeom prst="rect">
             <a:avLst/>
           </a:prstGeom>
           <a:solidFill>
-            <a:srgbClr val="1C2B3A"/>
+            <a:srgbClr val="C8A84B"/>
           </a:solidFill>
           <a:ln>
             <a:noFill/>
@@ -3661,90 +3593,142 @@
       </p:sp>
       <p:sp>
         <p:nvSpPr>
-          <p:cNvPr id="2" name="Title 1"/>
-          <p:cNvSpPr>
-            <a:spLocks noGrp="1"/>
-          </p:cNvSpPr>
-          <p:nvPr>
-            <p:ph type="title"/>
-          </p:nvPr>
-        </p:nvSpPr>
-        <p:spPr/>
-        <p:txBody>
-          <a:bodyPr/>
-          <a:lstStyle/>
-          <a:p>
-            <a:r>
-              <a:rPr sz="3600" b="1">
+          <p:cNvPr id="4" name="TextBox 3"/>
+          <p:cNvSpPr txBox="1"/>
+          <p:nvPr/>
+        </p:nvSpPr>
+        <p:spPr>
+          <a:xfrm>
+            <a:off x="594360" y="1714500"/>
+            <a:ext cx="502920" cy="502920"/>
+          </a:xfrm>
+          <a:prstGeom prst="rect">
+            <a:avLst/>
+          </a:prstGeom>
+          <a:noFill/>
+        </p:spPr>
+        <p:txBody>
+          <a:bodyPr wrap="square"/>
+          <a:lstStyle/>
+          <a:p>
+            <a:pPr algn="ctr"/>
+            <a:r>
+              <a:rPr sz="2600" b="1" i="0">
+                <a:solidFill>
+                  <a:srgbClr val="1C2B3A"/>
+                </a:solidFill>
+                <a:latin typeface="Georgia"/>
+              </a:rPr>
+              <a:t>2</a:t>
+            </a:r>
+          </a:p>
+        </p:txBody>
+      </p:sp>
+      <p:sp>
+        <p:nvSpPr>
+          <p:cNvPr id="5" name="TextBox 4"/>
+          <p:cNvSpPr txBox="1"/>
+          <p:nvPr/>
+        </p:nvSpPr>
+        <p:spPr>
+          <a:xfrm>
+            <a:off x="1371600" y="1508760"/>
+            <a:ext cx="7178040" cy="1463040"/>
+          </a:xfrm>
+          <a:prstGeom prst="rect">
+            <a:avLst/>
+          </a:prstGeom>
+          <a:noFill/>
+        </p:spPr>
+        <p:txBody>
+          <a:bodyPr wrap="square"/>
+          <a:lstStyle/>
+          <a:p>
+            <a:pPr algn="l"/>
+            <a:r>
+              <a:rPr sz="4400" b="1" i="0">
+                <a:solidFill>
+                  <a:srgbClr val="C8A84B"/>
+                </a:solidFill>
+                <a:latin typeface="Georgia"/>
+              </a:rPr>
+              <a:t>Market Analysis</a:t>
+            </a:r>
+          </a:p>
+        </p:txBody>
+      </p:sp>
+      <p:sp>
+        <p:nvSpPr>
+          <p:cNvPr id="6" name="TextBox 5"/>
+          <p:cNvSpPr txBox="1"/>
+          <p:nvPr/>
+        </p:nvSpPr>
+        <p:spPr>
+          <a:xfrm>
+            <a:off x="594360" y="4251960"/>
+            <a:ext cx="7955280" cy="822960"/>
+          </a:xfrm>
+          <a:prstGeom prst="rect">
+            <a:avLst/>
+          </a:prstGeom>
+          <a:noFill/>
+        </p:spPr>
+        <p:txBody>
+          <a:bodyPr wrap="square"/>
+          <a:lstStyle/>
+          <a:p>
+            <a:pPr algn="l"/>
+            <a:r>
+              <a:rPr sz="2000" b="0" i="1">
                 <a:solidFill>
                   <a:srgbClr val="FFFFFF"/>
                 </a:solidFill>
-                <a:latin typeface="Georgia"/>
-              </a:rPr>
-              <a:t>Roadmap</a:t>
-            </a:r>
-          </a:p>
-        </p:txBody>
-      </p:sp>
-      <p:sp>
-        <p:nvSpPr>
-          <p:cNvPr id="3" name="Content Placeholder 2"/>
-          <p:cNvSpPr>
-            <a:spLocks noGrp="1"/>
-          </p:cNvSpPr>
-          <p:nvPr>
-            <p:ph idx="1"/>
-          </p:nvPr>
-        </p:nvSpPr>
-        <p:spPr/>
-        <p:txBody>
-          <a:bodyPr/>
-          <a:lstStyle/>
-          <a:p>
-            <a:r>
-              <a:rPr sz="1800">
-                <a:solidFill>
-                  <a:srgbClr val="1C2B3A"/>
-                </a:solidFill>
                 <a:latin typeface="Trebuchet MS"/>
               </a:rPr>
-              <a:t>— Phase 1 : Q1</a:t>
-            </a:r>
-          </a:p>
-          <a:p>
-            <a:r>
-              <a:rPr sz="1800">
-                <a:solidFill>
-                  <a:srgbClr val="1C2B3A"/>
-                </a:solidFill>
-                <a:latin typeface="Trebuchet MS"/>
-              </a:rPr>
-              <a:t>— Phase 2 : Q2</a:t>
-            </a:r>
-          </a:p>
-          <a:p>
-            <a:r>
-              <a:rPr sz="1800">
-                <a:solidFill>
-                  <a:srgbClr val="1C2B3A"/>
-                </a:solidFill>
-                <a:latin typeface="Trebuchet MS"/>
-              </a:rPr>
-              <a:t>— Phase 3 : Q3</a:t>
-            </a:r>
-          </a:p>
-        </p:txBody>
-      </p:sp>
-      <p:sp>
-        <p:nvSpPr>
-          <p:cNvPr id="5" name="Rectangle 4"/>
+              <a:t>Croissance du marché observée sur les 3 derniers trimestres.</a:t>
+            </a:r>
+          </a:p>
+        </p:txBody>
+      </p:sp>
+    </p:spTree>
+  </p:cSld>
+  <p:clrMapOvr>
+    <a:masterClrMapping/>
+  </p:clrMapOvr>
+  <p:transition spd="med" dur="648">
+    <p:fade/>
+  </p:transition>
+</p:sld>
+</file>
+
+<file path=ppt/slides/slide4.xml><?xml version="1.0" encoding="utf-8"?>
+<p:sld xmlns:a="http://schemas.openxmlformats.org/drawingml/2006/main" xmlns:p="http://schemas.openxmlformats.org/presentationml/2006/main" xmlns:r="http://schemas.openxmlformats.org/officeDocument/2006/relationships">
+  <p:cSld>
+    <p:bg>
+      <p:bgPr>
+        <a:solidFill>
+          <a:srgbClr val="1C2B3A"/>
+        </a:solidFill>
+        <a:effectLst/>
+      </p:bgPr>
+    </p:bg>
+    <p:spTree>
+      <p:nvGrpSpPr>
+        <p:cNvPr id="1" name=""/>
+        <p:cNvGrpSpPr/>
+        <p:nvPr/>
+      </p:nvGrpSpPr>
+      <p:grpSpPr/>
+      <p:sp>
+        <p:nvSpPr>
+          <p:cNvPr id="2" name="Rectangle 1"/>
           <p:cNvSpPr/>
           <p:nvPr/>
         </p:nvSpPr>
         <p:spPr>
           <a:xfrm>
-            <a:off x="0" y="6781800"/>
-            <a:ext cx="9144000" cy="76200"/>
+            <a:off x="0" y="5623560"/>
+            <a:ext cx="9144000" cy="1234440"/>
           </a:xfrm>
           <a:prstGeom prst="rect">
             <a:avLst/>
@@ -3778,11 +3762,156 @@
           </a:p>
         </p:txBody>
       </p:sp>
+      <p:sp>
+        <p:nvSpPr>
+          <p:cNvPr id="3" name="Rectangle 2"/>
+          <p:cNvSpPr/>
+          <p:nvPr/>
+        </p:nvSpPr>
+        <p:spPr>
+          <a:xfrm>
+            <a:off x="594360" y="1714500"/>
+            <a:ext cx="502920" cy="502920"/>
+          </a:xfrm>
+          <a:prstGeom prst="rect">
+            <a:avLst/>
+          </a:prstGeom>
+          <a:solidFill>
+            <a:srgbClr val="C8A84B"/>
+          </a:solidFill>
+          <a:ln>
+            <a:noFill/>
+          </a:ln>
+        </p:spPr>
+        <p:style>
+          <a:lnRef idx="1">
+            <a:schemeClr val="accent1"/>
+          </a:lnRef>
+          <a:fillRef idx="3">
+            <a:schemeClr val="accent1"/>
+          </a:fillRef>
+          <a:effectRef idx="2">
+            <a:schemeClr val="accent1"/>
+          </a:effectRef>
+          <a:fontRef idx="minor">
+            <a:schemeClr val="lt1"/>
+          </a:fontRef>
+        </p:style>
+        <p:txBody>
+          <a:bodyPr rtlCol="0" anchor="ctr"/>
+          <a:lstStyle/>
+          <a:p>
+            <a:pPr algn="ctr"/>
+          </a:p>
+        </p:txBody>
+      </p:sp>
+      <p:sp>
+        <p:nvSpPr>
+          <p:cNvPr id="4" name="TextBox 3"/>
+          <p:cNvSpPr txBox="1"/>
+          <p:nvPr/>
+        </p:nvSpPr>
+        <p:spPr>
+          <a:xfrm>
+            <a:off x="594360" y="1714500"/>
+            <a:ext cx="502920" cy="502920"/>
+          </a:xfrm>
+          <a:prstGeom prst="rect">
+            <a:avLst/>
+          </a:prstGeom>
+          <a:noFill/>
+        </p:spPr>
+        <p:txBody>
+          <a:bodyPr wrap="square"/>
+          <a:lstStyle/>
+          <a:p>
+            <a:pPr algn="ctr"/>
+            <a:r>
+              <a:rPr sz="2600" b="1" i="0">
+                <a:solidFill>
+                  <a:srgbClr val="1C2B3A"/>
+                </a:solidFill>
+                <a:latin typeface="Georgia"/>
+              </a:rPr>
+              <a:t>3</a:t>
+            </a:r>
+          </a:p>
+        </p:txBody>
+      </p:sp>
+      <p:sp>
+        <p:nvSpPr>
+          <p:cNvPr id="5" name="TextBox 4"/>
+          <p:cNvSpPr txBox="1"/>
+          <p:nvPr/>
+        </p:nvSpPr>
+        <p:spPr>
+          <a:xfrm>
+            <a:off x="1371600" y="1508760"/>
+            <a:ext cx="7178040" cy="1463040"/>
+          </a:xfrm>
+          <a:prstGeom prst="rect">
+            <a:avLst/>
+          </a:prstGeom>
+          <a:noFill/>
+        </p:spPr>
+        <p:txBody>
+          <a:bodyPr wrap="square"/>
+          <a:lstStyle/>
+          <a:p>
+            <a:pPr algn="l"/>
+            <a:r>
+              <a:rPr sz="4400" b="1" i="0">
+                <a:solidFill>
+                  <a:srgbClr val="C8A84B"/>
+                </a:solidFill>
+                <a:latin typeface="Georgia"/>
+              </a:rPr>
+              <a:t>Roadmap</a:t>
+            </a:r>
+          </a:p>
+        </p:txBody>
+      </p:sp>
+      <p:sp>
+        <p:nvSpPr>
+          <p:cNvPr id="6" name="TextBox 5"/>
+          <p:cNvSpPr txBox="1"/>
+          <p:nvPr/>
+        </p:nvSpPr>
+        <p:spPr>
+          <a:xfrm>
+            <a:off x="594360" y="4251960"/>
+            <a:ext cx="7955280" cy="822960"/>
+          </a:xfrm>
+          <a:prstGeom prst="rect">
+            <a:avLst/>
+          </a:prstGeom>
+          <a:noFill/>
+        </p:spPr>
+        <p:txBody>
+          <a:bodyPr wrap="square"/>
+          <a:lstStyle/>
+          <a:p>
+            <a:pPr algn="l"/>
+            <a:r>
+              <a:rPr sz="2000" b="0" i="1">
+                <a:solidFill>
+                  <a:srgbClr val="FFFFFF"/>
+                </a:solidFill>
+                <a:latin typeface="Trebuchet MS"/>
+              </a:rPr>
+              <a:t>• Phase 1 : Q1</a:t>
+            </a:r>
+          </a:p>
+        </p:txBody>
+      </p:sp>
     </p:spTree>
   </p:cSld>
   <p:clrMapOvr>
     <a:masterClrMapping/>
   </p:clrMapOvr>
+  <p:transition spd="med" dur="413">
+    <p:fade/>
+  </p:transition>
 </p:sld>
 </file>
 
@@ -3806,58 +3935,14 @@
       <p:grpSpPr/>
       <p:sp>
         <p:nvSpPr>
-          <p:cNvPr id="2" name="Title 1"/>
-          <p:cNvSpPr>
-            <a:spLocks noGrp="1"/>
-          </p:cNvSpPr>
-          <p:nvPr>
-            <p:ph type="ctrTitle"/>
-          </p:nvPr>
-        </p:nvSpPr>
-        <p:spPr/>
-        <p:txBody>
-          <a:bodyPr/>
-          <a:lstStyle/>
-          <a:p>
-            <a:r>
-              <a:rPr sz="5200" b="1">
-                <a:solidFill>
-                  <a:srgbClr val="C8A84B"/>
-                </a:solidFill>
-                <a:latin typeface="Georgia"/>
-              </a:rPr>
-              <a:t>Merci</a:t>
-            </a:r>
-          </a:p>
-        </p:txBody>
-      </p:sp>
-      <p:sp>
-        <p:nvSpPr>
-          <p:cNvPr id="3" name="Subtitle 2"/>
-          <p:cNvSpPr>
-            <a:spLocks noGrp="1"/>
-          </p:cNvSpPr>
-          <p:nvPr>
-            <p:ph type="subTitle" idx="1"/>
-          </p:nvPr>
-        </p:nvSpPr>
-        <p:spPr/>
-        <p:txBody>
-          <a:bodyPr/>
-          <a:lstStyle/>
-          <a:p/>
-        </p:txBody>
-      </p:sp>
-      <p:sp>
-        <p:nvSpPr>
-          <p:cNvPr id="4" name="Rectangle 3"/>
+          <p:cNvPr id="2" name="Rectangle 1"/>
           <p:cNvSpPr/>
           <p:nvPr/>
         </p:nvSpPr>
         <p:spPr>
           <a:xfrm>
             <a:off x="0" y="0"/>
-            <a:ext cx="109728" cy="6858000"/>
+            <a:ext cx="9144000" cy="548640"/>
           </a:xfrm>
           <a:prstGeom prst="rect">
             <a:avLst/>
@@ -3893,14 +3978,14 @@
       </p:sp>
       <p:sp>
         <p:nvSpPr>
-          <p:cNvPr id="5" name="Rectangle 4"/>
+          <p:cNvPr id="3" name="Rectangle 2"/>
           <p:cNvSpPr/>
           <p:nvPr/>
         </p:nvSpPr>
         <p:spPr>
           <a:xfrm>
-            <a:off x="0" y="6781800"/>
-            <a:ext cx="9144000" cy="76200"/>
+            <a:off x="0" y="0"/>
+            <a:ext cx="64008" cy="6858000"/>
           </a:xfrm>
           <a:prstGeom prst="rect">
             <a:avLst/>
@@ -3934,12 +4019,88 @@
           </a:p>
         </p:txBody>
       </p:sp>
+      <p:sp>
+        <p:nvSpPr>
+          <p:cNvPr id="4" name="Rectangle 3"/>
+          <p:cNvSpPr/>
+          <p:nvPr/>
+        </p:nvSpPr>
+        <p:spPr>
+          <a:xfrm>
+            <a:off x="2286000" y="2880360"/>
+            <a:ext cx="4572000" cy="228600"/>
+          </a:xfrm>
+          <a:prstGeom prst="rect">
+            <a:avLst/>
+          </a:prstGeom>
+          <a:solidFill>
+            <a:srgbClr val="C8A84B"/>
+          </a:solidFill>
+          <a:ln>
+            <a:noFill/>
+          </a:ln>
+        </p:spPr>
+        <p:style>
+          <a:lnRef idx="1">
+            <a:schemeClr val="accent1"/>
+          </a:lnRef>
+          <a:fillRef idx="3">
+            <a:schemeClr val="accent1"/>
+          </a:fillRef>
+          <a:effectRef idx="2">
+            <a:schemeClr val="accent1"/>
+          </a:effectRef>
+          <a:fontRef idx="minor">
+            <a:schemeClr val="lt1"/>
+          </a:fontRef>
+        </p:style>
+        <p:txBody>
+          <a:bodyPr rtlCol="0" anchor="ctr"/>
+          <a:lstStyle/>
+          <a:p>
+            <a:pPr algn="ctr"/>
+          </a:p>
+        </p:txBody>
+      </p:sp>
+      <p:sp>
+        <p:nvSpPr>
+          <p:cNvPr id="5" name="TextBox 4"/>
+          <p:cNvSpPr txBox="1"/>
+          <p:nvPr/>
+        </p:nvSpPr>
+        <p:spPr>
+          <a:xfrm>
+            <a:off x="1024128" y="3337560"/>
+            <a:ext cx="7525512" cy="1645920"/>
+          </a:xfrm>
+          <a:prstGeom prst="rect">
+            <a:avLst/>
+          </a:prstGeom>
+          <a:noFill/>
+        </p:spPr>
+        <p:txBody>
+          <a:bodyPr wrap="square"/>
+          <a:lstStyle/>
+          <a:p>
+            <a:pPr algn="ctr"/>
+            <a:r>
+              <a:rPr sz="4800" b="1" i="0">
+                <a:solidFill>
+                  <a:srgbClr val="C8A84B"/>
+                </a:solidFill>
+                <a:latin typeface="Georgia"/>
+              </a:rPr>
+              <a:t>Merci</a:t>
+            </a:r>
+          </a:p>
+        </p:txBody>
+      </p:sp>
     </p:spTree>
   </p:cSld>
   <p:clrMapOvr>
     <a:masterClrMapping/>
   </p:clrMapOvr>
-  <p:transition spd="med" dur="668">
+  <p:transition spd="med" dur="678">
     <p:fade/>
   </p:transition>
 </p:sld>

</xml_diff>

<commit_message>
chore: update test output
https://claude.ai/code/session_01Ku7J1XKnJyhda2UCdNL7n9
</commit_message>
<xml_diff>
--- a/input/test_corporate_redesigned.pptx
+++ b/input/test_corporate_redesigned.pptx
@@ -3088,7 +3088,7 @@
     <p:bg>
       <p:bgPr>
         <a:solidFill>
-          <a:srgbClr val="1C2B3A"/>
+          <a:srgbClr val="0F1923"/>
         </a:solidFill>
         <a:effectLst/>
       </p:bgPr>
@@ -3102,20 +3102,22 @@
       <p:grpSpPr/>
       <p:sp>
         <p:nvSpPr>
-          <p:cNvPr id="2" name="Rectangle 1"/>
+          <p:cNvPr id="4" name="Oval 3"/>
           <p:cNvSpPr/>
           <p:nvPr/>
         </p:nvSpPr>
         <p:spPr>
           <a:xfrm>
-            <a:off x="0" y="0"/>
-            <a:ext cx="64008" cy="6858000"/>
-          </a:xfrm>
-          <a:prstGeom prst="rect">
+            <a:off x="-548640" y="4937760"/>
+            <a:ext cx="2194560" cy="2194560"/>
+          </a:xfrm>
+          <a:prstGeom prst="ellipse">
             <a:avLst/>
           </a:prstGeom>
           <a:solidFill>
-            <a:srgbClr val="C8A84B"/>
+            <a:srgbClr val="D4893A">
+              <a:alpha val="35000"/>
+            </a:srgbClr>
           </a:solidFill>
           <a:ln>
             <a:noFill/>
@@ -3145,20 +3147,22 @@
       </p:sp>
       <p:sp>
         <p:nvSpPr>
-          <p:cNvPr id="3" name="Rectangle 2"/>
+          <p:cNvPr id="3" name="Oval 2"/>
           <p:cNvSpPr/>
           <p:nvPr/>
         </p:nvSpPr>
         <p:spPr>
           <a:xfrm>
-            <a:off x="0" y="6705600"/>
-            <a:ext cx="9144000" cy="152400"/>
-          </a:xfrm>
-          <a:prstGeom prst="rect">
+            <a:off x="6583680" y="3086100"/>
+            <a:ext cx="4457700" cy="4457700"/>
+          </a:xfrm>
+          <a:prstGeom prst="ellipse">
             <a:avLst/>
           </a:prstGeom>
           <a:solidFill>
-            <a:srgbClr val="C8A84B"/>
+            <a:srgbClr val="8AABB5">
+              <a:alpha val="22000"/>
+            </a:srgbClr>
           </a:solidFill>
           <a:ln>
             <a:noFill/>
@@ -3188,20 +3192,22 @@
       </p:sp>
       <p:sp>
         <p:nvSpPr>
-          <p:cNvPr id="4" name="Rectangle 3"/>
+          <p:cNvPr id="2" name="Oval 1"/>
           <p:cNvSpPr/>
           <p:nvPr/>
         </p:nvSpPr>
         <p:spPr>
           <a:xfrm>
-            <a:off x="841248" y="2880360"/>
-            <a:ext cx="4114800" cy="152400"/>
-          </a:xfrm>
-          <a:prstGeom prst="rect">
+            <a:off x="5669280" y="-1028700"/>
+            <a:ext cx="6515100" cy="6515100"/>
+          </a:xfrm>
+          <a:prstGeom prst="ellipse">
             <a:avLst/>
           </a:prstGeom>
           <a:solidFill>
-            <a:srgbClr val="C8A84B"/>
+            <a:srgbClr val="D4893A">
+              <a:alpha val="18000"/>
+            </a:srgbClr>
           </a:solidFill>
           <a:ln>
             <a:noFill/>
@@ -3231,14 +3237,57 @@
       </p:sp>
       <p:sp>
         <p:nvSpPr>
-          <p:cNvPr id="5" name="TextBox 4"/>
+          <p:cNvPr id="5" name="Rectangle 4"/>
+          <p:cNvSpPr/>
+          <p:nvPr/>
+        </p:nvSpPr>
+        <p:spPr>
+          <a:xfrm>
+            <a:off x="685800" y="3154680"/>
+            <a:ext cx="5029200" cy="55000"/>
+          </a:xfrm>
+          <a:prstGeom prst="rect">
+            <a:avLst/>
+          </a:prstGeom>
+          <a:solidFill>
+            <a:srgbClr val="D4893A"/>
+          </a:solidFill>
+          <a:ln>
+            <a:noFill/>
+          </a:ln>
+        </p:spPr>
+        <p:style>
+          <a:lnRef idx="1">
+            <a:schemeClr val="accent1"/>
+          </a:lnRef>
+          <a:fillRef idx="3">
+            <a:schemeClr val="accent1"/>
+          </a:fillRef>
+          <a:effectRef idx="2">
+            <a:schemeClr val="accent1"/>
+          </a:effectRef>
+          <a:fontRef idx="minor">
+            <a:schemeClr val="lt1"/>
+          </a:fontRef>
+        </p:style>
+        <p:txBody>
+          <a:bodyPr rtlCol="0" anchor="ctr"/>
+          <a:lstStyle/>
+          <a:p>
+            <a:pPr algn="ctr"/>
+          </a:p>
+        </p:txBody>
+      </p:sp>
+      <p:sp>
+        <p:nvSpPr>
+          <p:cNvPr id="6" name="TextBox 5"/>
           <p:cNvSpPr txBox="1"/>
           <p:nvPr/>
         </p:nvSpPr>
         <p:spPr>
           <a:xfrm>
-            <a:off x="978408" y="3169920"/>
-            <a:ext cx="7571232" cy="2011680"/>
+            <a:off x="685800" y="3234680"/>
+            <a:ext cx="5943600" cy="2194560"/>
           </a:xfrm>
           <a:prstGeom prst="rect">
             <a:avLst/>
@@ -3246,19 +3295,66 @@
           <a:noFill/>
         </p:spPr>
         <p:txBody>
-          <a:bodyPr wrap="square"/>
+          <a:bodyPr wrap="square">
+            <a:spAutoFit/>
+          </a:bodyPr>
           <a:lstStyle/>
           <a:p>
             <a:pPr algn="l"/>
             <a:r>
-              <a:rPr sz="4800" b="1" i="0">
+              <a:rPr sz="5200" b="1" i="0">
                 <a:solidFill>
-                  <a:srgbClr val="C8A84B"/>
+                  <a:srgbClr val="D4893A"/>
                 </a:solidFill>
                 <a:latin typeface="Georgia"/>
               </a:rPr>
               <a:t>Stratégie Q3 2025</a:t>
             </a:r>
+          </a:p>
+        </p:txBody>
+      </p:sp>
+      <p:sp>
+        <p:nvSpPr>
+          <p:cNvPr id="7" name="Rectangle 6"/>
+          <p:cNvSpPr/>
+          <p:nvPr/>
+        </p:nvSpPr>
+        <p:spPr>
+          <a:xfrm>
+            <a:off x="0" y="6693408"/>
+            <a:ext cx="9144000" cy="164592"/>
+          </a:xfrm>
+          <a:prstGeom prst="rect">
+            <a:avLst/>
+          </a:prstGeom>
+          <a:solidFill>
+            <a:srgbClr val="8AABB5">
+              <a:alpha val="70000"/>
+            </a:srgbClr>
+          </a:solidFill>
+          <a:ln>
+            <a:noFill/>
+          </a:ln>
+        </p:spPr>
+        <p:style>
+          <a:lnRef idx="1">
+            <a:schemeClr val="accent1"/>
+          </a:lnRef>
+          <a:fillRef idx="3">
+            <a:schemeClr val="accent1"/>
+          </a:fillRef>
+          <a:effectRef idx="2">
+            <a:schemeClr val="accent1"/>
+          </a:effectRef>
+          <a:fontRef idx="minor">
+            <a:schemeClr val="lt1"/>
+          </a:fontRef>
+        </p:style>
+        <p:txBody>
+          <a:bodyPr rtlCol="0" anchor="ctr"/>
+          <a:lstStyle/>
+          <a:p>
+            <a:pPr algn="ctr"/>
           </a:p>
         </p:txBody>
       </p:sp>
@@ -3267,7 +3363,7 @@
   <p:clrMapOvr>
     <a:masterClrMapping/>
   </p:clrMapOvr>
-  <p:transition spd="med" dur="633">
+  <p:transition spd="med" dur="457">
     <p:fade/>
   </p:transition>
 </p:sld>
@@ -3279,7 +3375,7 @@
     <p:bg>
       <p:bgPr>
         <a:solidFill>
-          <a:srgbClr val="1C2B3A"/>
+          <a:srgbClr val="EDEAE0"/>
         </a:solidFill>
         <a:effectLst/>
       </p:bgPr>
@@ -3293,20 +3389,55 @@
       <p:grpSpPr/>
       <p:sp>
         <p:nvSpPr>
-          <p:cNvPr id="2" name="Rectangle 1"/>
+          <p:cNvPr id="2" name="TextBox 1"/>
+          <p:cNvSpPr txBox="1"/>
+          <p:nvPr/>
+        </p:nvSpPr>
+        <p:spPr>
+          <a:xfrm>
+            <a:off x="6583680" y="548640"/>
+            <a:ext cx="2194560" cy="2286000"/>
+          </a:xfrm>
+          <a:prstGeom prst="rect">
+            <a:avLst/>
+          </a:prstGeom>
+          <a:noFill/>
+        </p:spPr>
+        <p:txBody>
+          <a:bodyPr wrap="square">
+            <a:spAutoFit/>
+          </a:bodyPr>
+          <a:lstStyle/>
+          <a:p>
+            <a:pPr algn="r"/>
+            <a:r>
+              <a:rPr sz="10500" b="1" i="0">
+                <a:solidFill>
+                  <a:srgbClr val="E2E3E4"/>
+                </a:solidFill>
+                <a:latin typeface="Georgia"/>
+              </a:rPr>
+              <a:t>01</a:t>
+            </a:r>
+          </a:p>
+        </p:txBody>
+      </p:sp>
+      <p:sp>
+        <p:nvSpPr>
+          <p:cNvPr id="3" name="Rectangle 2"/>
           <p:cNvSpPr/>
           <p:nvPr/>
         </p:nvSpPr>
         <p:spPr>
           <a:xfrm>
-            <a:off x="0" y="5623560"/>
-            <a:ext cx="9144000" cy="1234440"/>
+            <a:off x="0" y="0"/>
+            <a:ext cx="82296" cy="6858000"/>
           </a:xfrm>
           <a:prstGeom prst="rect">
             <a:avLst/>
           </a:prstGeom>
           <a:solidFill>
-            <a:srgbClr val="C8A84B"/>
+            <a:srgbClr val="D4893A"/>
           </a:solidFill>
           <a:ln>
             <a:noFill/>
@@ -3336,20 +3467,55 @@
       </p:sp>
       <p:sp>
         <p:nvSpPr>
-          <p:cNvPr id="3" name="Rectangle 2"/>
+          <p:cNvPr id="4" name="TextBox 3"/>
+          <p:cNvSpPr txBox="1"/>
+          <p:nvPr/>
+        </p:nvSpPr>
+        <p:spPr>
+          <a:xfrm>
+            <a:off x="685800" y="502920"/>
+            <a:ext cx="6217920" cy="1005840"/>
+          </a:xfrm>
+          <a:prstGeom prst="rect">
+            <a:avLst/>
+          </a:prstGeom>
+          <a:noFill/>
+        </p:spPr>
+        <p:txBody>
+          <a:bodyPr wrap="square">
+            <a:spAutoFit/>
+          </a:bodyPr>
+          <a:lstStyle/>
+          <a:p>
+            <a:pPr algn="l"/>
+            <a:r>
+              <a:rPr sz="3000" b="1" i="0">
+                <a:solidFill>
+                  <a:srgbClr val="0F1923"/>
+                </a:solidFill>
+                <a:latin typeface="Georgia"/>
+              </a:rPr>
+              <a:t>KPI Revenue</a:t>
+            </a:r>
+          </a:p>
+        </p:txBody>
+      </p:sp>
+      <p:sp>
+        <p:nvSpPr>
+          <p:cNvPr id="5" name="Rectangle 4"/>
           <p:cNvSpPr/>
           <p:nvPr/>
         </p:nvSpPr>
         <p:spPr>
           <a:xfrm>
-            <a:off x="594360" y="1714500"/>
-            <a:ext cx="502920" cy="502920"/>
+            <a:off x="685800" y="1554480"/>
+            <a:ext cx="1645920" cy="50000"/>
           </a:xfrm>
           <a:prstGeom prst="rect">
             <a:avLst/>
           </a:prstGeom>
           <a:solidFill>
-            <a:srgbClr val="C8A84B"/>
+            <a:srgbClr val="D4893A"/>
           </a:solidFill>
           <a:ln>
             <a:noFill/>
@@ -3379,14 +3545,57 @@
       </p:sp>
       <p:sp>
         <p:nvSpPr>
-          <p:cNvPr id="4" name="TextBox 3"/>
+          <p:cNvPr id="6" name="Rectangle 5"/>
+          <p:cNvSpPr/>
+          <p:nvPr/>
+        </p:nvSpPr>
+        <p:spPr>
+          <a:xfrm>
+            <a:off x="2377440" y="1554480"/>
+            <a:ext cx="6080760" cy="50000"/>
+          </a:xfrm>
+          <a:prstGeom prst="rect">
+            <a:avLst/>
+          </a:prstGeom>
+          <a:solidFill>
+            <a:srgbClr val="D3D5D7"/>
+          </a:solidFill>
+          <a:ln>
+            <a:noFill/>
+          </a:ln>
+        </p:spPr>
+        <p:style>
+          <a:lnRef idx="1">
+            <a:schemeClr val="accent1"/>
+          </a:lnRef>
+          <a:fillRef idx="3">
+            <a:schemeClr val="accent1"/>
+          </a:fillRef>
+          <a:effectRef idx="2">
+            <a:schemeClr val="accent1"/>
+          </a:effectRef>
+          <a:fontRef idx="minor">
+            <a:schemeClr val="lt1"/>
+          </a:fontRef>
+        </p:style>
+        <p:txBody>
+          <a:bodyPr rtlCol="0" anchor="ctr"/>
+          <a:lstStyle/>
+          <a:p>
+            <a:pPr algn="ctr"/>
+          </a:p>
+        </p:txBody>
+      </p:sp>
+      <p:sp>
+        <p:nvSpPr>
+          <p:cNvPr id="7" name="TextBox 6"/>
           <p:cNvSpPr txBox="1"/>
           <p:nvPr/>
         </p:nvSpPr>
         <p:spPr>
           <a:xfrm>
-            <a:off x="594360" y="1714500"/>
-            <a:ext cx="502920" cy="502920"/>
+            <a:off x="777240" y="1920240"/>
+            <a:ext cx="7589520" cy="4434840"/>
           </a:xfrm>
           <a:prstGeom prst="rect">
             <a:avLst/>
@@ -3394,85 +3603,100 @@
           <a:noFill/>
         </p:spPr>
         <p:txBody>
-          <a:bodyPr wrap="square"/>
-          <a:lstStyle/>
-          <a:p>
-            <a:pPr algn="ctr"/>
-            <a:r>
-              <a:rPr sz="2600" b="1" i="0">
+          <a:bodyPr wrap="square">
+            <a:spAutoFit/>
+          </a:bodyPr>
+          <a:lstStyle/>
+          <a:p>
+            <a:pPr algn="l">
+              <a:spcBef>
+                <a:spcPts val="0"/>
+              </a:spcBef>
+            </a:pPr>
+            <a:r>
+              <a:rPr sz="1800" b="0">
                 <a:solidFill>
-                  <a:srgbClr val="1C2B3A"/>
-                </a:solidFill>
-                <a:latin typeface="Georgia"/>
-              </a:rPr>
-              <a:t>1</a:t>
-            </a:r>
-          </a:p>
-        </p:txBody>
-      </p:sp>
-      <p:sp>
-        <p:nvSpPr>
-          <p:cNvPr id="5" name="TextBox 4"/>
-          <p:cNvSpPr txBox="1"/>
-          <p:nvPr/>
-        </p:nvSpPr>
-        <p:spPr>
-          <a:xfrm>
-            <a:off x="1371600" y="1508760"/>
-            <a:ext cx="7178040" cy="1463040"/>
-          </a:xfrm>
-          <a:prstGeom prst="rect">
-            <a:avLst/>
-          </a:prstGeom>
-          <a:noFill/>
-        </p:spPr>
-        <p:txBody>
-          <a:bodyPr wrap="square"/>
-          <a:lstStyle/>
-          <a:p>
-            <a:pPr algn="l"/>
-            <a:r>
-              <a:rPr sz="4400" b="1" i="0">
-                <a:solidFill>
-                  <a:srgbClr val="C8A84B"/>
-                </a:solidFill>
-                <a:latin typeface="Georgia"/>
-              </a:rPr>
-              <a:t>KPI Revenue</a:t>
-            </a:r>
-          </a:p>
-        </p:txBody>
-      </p:sp>
-      <p:sp>
-        <p:nvSpPr>
-          <p:cNvPr id="6" name="TextBox 5"/>
-          <p:cNvSpPr txBox="1"/>
-          <p:nvPr/>
-        </p:nvSpPr>
-        <p:spPr>
-          <a:xfrm>
-            <a:off x="594360" y="4251960"/>
-            <a:ext cx="7955280" cy="822960"/>
-          </a:xfrm>
-          <a:prstGeom prst="rect">
-            <a:avLst/>
-          </a:prstGeom>
-          <a:noFill/>
-        </p:spPr>
-        <p:txBody>
-          <a:bodyPr wrap="square"/>
-          <a:lstStyle/>
-          <a:p>
-            <a:pPr algn="l"/>
-            <a:r>
-              <a:rPr sz="2000" b="0" i="1">
-                <a:solidFill>
-                  <a:srgbClr val="FFFFFF"/>
+                  <a:srgbClr val="0F1923"/>
                 </a:solidFill>
                 <a:latin typeface="Trebuchet MS"/>
               </a:rPr>
-              <a:t>• Chiffre d'affaires +15%</a:t>
-            </a:r>
+              <a:t>— Chiffre d'affaires +15%</a:t>
+            </a:r>
+          </a:p>
+          <a:p>
+            <a:pPr algn="l">
+              <a:spcBef>
+                <a:spcPts val="900"/>
+              </a:spcBef>
+            </a:pPr>
+            <a:r>
+              <a:rPr sz="1800" b="0">
+                <a:solidFill>
+                  <a:srgbClr val="0F1923"/>
+                </a:solidFill>
+                <a:latin typeface="Trebuchet MS"/>
+              </a:rPr>
+              <a:t>— ROI amélioré</a:t>
+            </a:r>
+          </a:p>
+          <a:p>
+            <a:pPr algn="l">
+              <a:spcBef>
+                <a:spcPts val="900"/>
+              </a:spcBef>
+            </a:pPr>
+            <a:r>
+              <a:rPr sz="1800" b="0">
+                <a:solidFill>
+                  <a:srgbClr val="0F1923"/>
+                </a:solidFill>
+                <a:latin typeface="Trebuchet MS"/>
+              </a:rPr>
+              <a:t>— Budget optimisé</a:t>
+            </a:r>
+          </a:p>
+        </p:txBody>
+      </p:sp>
+      <p:sp>
+        <p:nvSpPr>
+          <p:cNvPr id="8" name="Oval 7"/>
+          <p:cNvSpPr/>
+          <p:nvPr/>
+        </p:nvSpPr>
+        <p:spPr>
+          <a:xfrm>
+            <a:off x="8293608" y="6190488"/>
+            <a:ext cx="164592" cy="164592"/>
+          </a:xfrm>
+          <a:prstGeom prst="ellipse">
+            <a:avLst/>
+          </a:prstGeom>
+          <a:solidFill>
+            <a:srgbClr val="D4893A"/>
+          </a:solidFill>
+          <a:ln>
+            <a:noFill/>
+          </a:ln>
+        </p:spPr>
+        <p:style>
+          <a:lnRef idx="1">
+            <a:schemeClr val="accent1"/>
+          </a:lnRef>
+          <a:fillRef idx="3">
+            <a:schemeClr val="accent1"/>
+          </a:fillRef>
+          <a:effectRef idx="2">
+            <a:schemeClr val="accent1"/>
+          </a:effectRef>
+          <a:fontRef idx="minor">
+            <a:schemeClr val="lt1"/>
+          </a:fontRef>
+        </p:style>
+        <p:txBody>
+          <a:bodyPr rtlCol="0" anchor="ctr"/>
+          <a:lstStyle/>
+          <a:p>
+            <a:pPr algn="ctr"/>
           </a:p>
         </p:txBody>
       </p:sp>
@@ -3481,7 +3705,7 @@
   <p:clrMapOvr>
     <a:masterClrMapping/>
   </p:clrMapOvr>
-  <p:transition spd="med" dur="552">
+  <p:transition spd="med" dur="547">
     <p:fade/>
   </p:transition>
 </p:sld>
@@ -3493,7 +3717,7 @@
     <p:bg>
       <p:bgPr>
         <a:solidFill>
-          <a:srgbClr val="1C2B3A"/>
+          <a:srgbClr val="F8F6F0"/>
         </a:solidFill>
         <a:effectLst/>
       </p:bgPr>
@@ -3507,20 +3731,55 @@
       <p:grpSpPr/>
       <p:sp>
         <p:nvSpPr>
-          <p:cNvPr id="2" name="Rectangle 1"/>
+          <p:cNvPr id="2" name="TextBox 1"/>
+          <p:cNvSpPr txBox="1"/>
+          <p:nvPr/>
+        </p:nvSpPr>
+        <p:spPr>
+          <a:xfrm>
+            <a:off x="6583680" y="548640"/>
+            <a:ext cx="2194560" cy="2286000"/>
+          </a:xfrm>
+          <a:prstGeom prst="rect">
+            <a:avLst/>
+          </a:prstGeom>
+          <a:noFill/>
+        </p:spPr>
+        <p:txBody>
+          <a:bodyPr wrap="square">
+            <a:spAutoFit/>
+          </a:bodyPr>
+          <a:lstStyle/>
+          <a:p>
+            <a:pPr algn="r"/>
+            <a:r>
+              <a:rPr sz="10500" b="1" i="0">
+                <a:solidFill>
+                  <a:srgbClr val="E2E3E4"/>
+                </a:solidFill>
+                <a:latin typeface="Georgia"/>
+              </a:rPr>
+              <a:t>02</a:t>
+            </a:r>
+          </a:p>
+        </p:txBody>
+      </p:sp>
+      <p:sp>
+        <p:nvSpPr>
+          <p:cNvPr id="3" name="Rectangle 2"/>
           <p:cNvSpPr/>
           <p:nvPr/>
         </p:nvSpPr>
         <p:spPr>
           <a:xfrm>
-            <a:off x="0" y="5623560"/>
-            <a:ext cx="9144000" cy="1234440"/>
+            <a:off x="0" y="0"/>
+            <a:ext cx="82296" cy="6858000"/>
           </a:xfrm>
           <a:prstGeom prst="rect">
             <a:avLst/>
           </a:prstGeom>
           <a:solidFill>
-            <a:srgbClr val="C8A84B"/>
+            <a:srgbClr val="D4893A"/>
           </a:solidFill>
           <a:ln>
             <a:noFill/>
@@ -3550,20 +3809,55 @@
       </p:sp>
       <p:sp>
         <p:nvSpPr>
-          <p:cNvPr id="3" name="Rectangle 2"/>
+          <p:cNvPr id="4" name="TextBox 3"/>
+          <p:cNvSpPr txBox="1"/>
+          <p:nvPr/>
+        </p:nvSpPr>
+        <p:spPr>
+          <a:xfrm>
+            <a:off x="685800" y="502920"/>
+            <a:ext cx="6217920" cy="1005840"/>
+          </a:xfrm>
+          <a:prstGeom prst="rect">
+            <a:avLst/>
+          </a:prstGeom>
+          <a:noFill/>
+        </p:spPr>
+        <p:txBody>
+          <a:bodyPr wrap="square">
+            <a:spAutoFit/>
+          </a:bodyPr>
+          <a:lstStyle/>
+          <a:p>
+            <a:pPr algn="l"/>
+            <a:r>
+              <a:rPr sz="3000" b="1" i="0">
+                <a:solidFill>
+                  <a:srgbClr val="0F1923"/>
+                </a:solidFill>
+                <a:latin typeface="Georgia"/>
+              </a:rPr>
+              <a:t>Market Analysis</a:t>
+            </a:r>
+          </a:p>
+        </p:txBody>
+      </p:sp>
+      <p:sp>
+        <p:nvSpPr>
+          <p:cNvPr id="5" name="Rectangle 4"/>
           <p:cNvSpPr/>
           <p:nvPr/>
         </p:nvSpPr>
         <p:spPr>
           <a:xfrm>
-            <a:off x="594360" y="1714500"/>
-            <a:ext cx="502920" cy="502920"/>
+            <a:off x="685800" y="1554480"/>
+            <a:ext cx="1645920" cy="50000"/>
           </a:xfrm>
           <a:prstGeom prst="rect">
             <a:avLst/>
           </a:prstGeom>
           <a:solidFill>
-            <a:srgbClr val="C8A84B"/>
+            <a:srgbClr val="D4893A"/>
           </a:solidFill>
           <a:ln>
             <a:noFill/>
@@ -3593,14 +3887,57 @@
       </p:sp>
       <p:sp>
         <p:nvSpPr>
-          <p:cNvPr id="4" name="TextBox 3"/>
+          <p:cNvPr id="6" name="Rectangle 5"/>
+          <p:cNvSpPr/>
+          <p:nvPr/>
+        </p:nvSpPr>
+        <p:spPr>
+          <a:xfrm>
+            <a:off x="2377440" y="1554480"/>
+            <a:ext cx="6080760" cy="50000"/>
+          </a:xfrm>
+          <a:prstGeom prst="rect">
+            <a:avLst/>
+          </a:prstGeom>
+          <a:solidFill>
+            <a:srgbClr val="D3D5D7"/>
+          </a:solidFill>
+          <a:ln>
+            <a:noFill/>
+          </a:ln>
+        </p:spPr>
+        <p:style>
+          <a:lnRef idx="1">
+            <a:schemeClr val="accent1"/>
+          </a:lnRef>
+          <a:fillRef idx="3">
+            <a:schemeClr val="accent1"/>
+          </a:fillRef>
+          <a:effectRef idx="2">
+            <a:schemeClr val="accent1"/>
+          </a:effectRef>
+          <a:fontRef idx="minor">
+            <a:schemeClr val="lt1"/>
+          </a:fontRef>
+        </p:style>
+        <p:txBody>
+          <a:bodyPr rtlCol="0" anchor="ctr"/>
+          <a:lstStyle/>
+          <a:p>
+            <a:pPr algn="ctr"/>
+          </a:p>
+        </p:txBody>
+      </p:sp>
+      <p:sp>
+        <p:nvSpPr>
+          <p:cNvPr id="7" name="TextBox 6"/>
           <p:cNvSpPr txBox="1"/>
           <p:nvPr/>
         </p:nvSpPr>
         <p:spPr>
           <a:xfrm>
-            <a:off x="594360" y="1714500"/>
-            <a:ext cx="502920" cy="502920"/>
+            <a:off x="777240" y="1920240"/>
+            <a:ext cx="7589520" cy="4434840"/>
           </a:xfrm>
           <a:prstGeom prst="rect">
             <a:avLst/>
@@ -3608,85 +3945,68 @@
           <a:noFill/>
         </p:spPr>
         <p:txBody>
-          <a:bodyPr wrap="square"/>
-          <a:lstStyle/>
-          <a:p>
-            <a:pPr algn="ctr"/>
-            <a:r>
-              <a:rPr sz="2600" b="1" i="0">
+          <a:bodyPr wrap="square">
+            <a:spAutoFit/>
+          </a:bodyPr>
+          <a:lstStyle/>
+          <a:p>
+            <a:pPr algn="l">
+              <a:spcBef>
+                <a:spcPts val="0"/>
+              </a:spcBef>
+            </a:pPr>
+            <a:r>
+              <a:rPr sz="1800" b="0">
                 <a:solidFill>
-                  <a:srgbClr val="1C2B3A"/>
-                </a:solidFill>
-                <a:latin typeface="Georgia"/>
-              </a:rPr>
-              <a:t>2</a:t>
-            </a:r>
-          </a:p>
-        </p:txBody>
-      </p:sp>
-      <p:sp>
-        <p:nvSpPr>
-          <p:cNvPr id="5" name="TextBox 4"/>
-          <p:cNvSpPr txBox="1"/>
-          <p:nvPr/>
-        </p:nvSpPr>
-        <p:spPr>
-          <a:xfrm>
-            <a:off x="1371600" y="1508760"/>
-            <a:ext cx="7178040" cy="1463040"/>
-          </a:xfrm>
-          <a:prstGeom prst="rect">
-            <a:avLst/>
-          </a:prstGeom>
-          <a:noFill/>
-        </p:spPr>
-        <p:txBody>
-          <a:bodyPr wrap="square"/>
-          <a:lstStyle/>
-          <a:p>
-            <a:pPr algn="l"/>
-            <a:r>
-              <a:rPr sz="4400" b="1" i="0">
-                <a:solidFill>
-                  <a:srgbClr val="C8A84B"/>
-                </a:solidFill>
-                <a:latin typeface="Georgia"/>
-              </a:rPr>
-              <a:t>Market Analysis</a:t>
-            </a:r>
-          </a:p>
-        </p:txBody>
-      </p:sp>
-      <p:sp>
-        <p:nvSpPr>
-          <p:cNvPr id="6" name="TextBox 5"/>
-          <p:cNvSpPr txBox="1"/>
-          <p:nvPr/>
-        </p:nvSpPr>
-        <p:spPr>
-          <a:xfrm>
-            <a:off x="594360" y="4251960"/>
-            <a:ext cx="7955280" cy="822960"/>
-          </a:xfrm>
-          <a:prstGeom prst="rect">
-            <a:avLst/>
-          </a:prstGeom>
-          <a:noFill/>
-        </p:spPr>
-        <p:txBody>
-          <a:bodyPr wrap="square"/>
-          <a:lstStyle/>
-          <a:p>
-            <a:pPr algn="l"/>
-            <a:r>
-              <a:rPr sz="2000" b="0" i="1">
-                <a:solidFill>
-                  <a:srgbClr val="FFFFFF"/>
+                  <a:srgbClr val="0F1923"/>
                 </a:solidFill>
                 <a:latin typeface="Trebuchet MS"/>
               </a:rPr>
               <a:t>Croissance du marché observée sur les 3 derniers trimestres.</a:t>
             </a:r>
+          </a:p>
+        </p:txBody>
+      </p:sp>
+      <p:sp>
+        <p:nvSpPr>
+          <p:cNvPr id="8" name="Oval 7"/>
+          <p:cNvSpPr/>
+          <p:nvPr/>
+        </p:nvSpPr>
+        <p:spPr>
+          <a:xfrm>
+            <a:off x="8293608" y="6190488"/>
+            <a:ext cx="164592" cy="164592"/>
+          </a:xfrm>
+          <a:prstGeom prst="ellipse">
+            <a:avLst/>
+          </a:prstGeom>
+          <a:solidFill>
+            <a:srgbClr val="D4893A"/>
+          </a:solidFill>
+          <a:ln>
+            <a:noFill/>
+          </a:ln>
+        </p:spPr>
+        <p:style>
+          <a:lnRef idx="1">
+            <a:schemeClr val="accent1"/>
+          </a:lnRef>
+          <a:fillRef idx="3">
+            <a:schemeClr val="accent1"/>
+          </a:fillRef>
+          <a:effectRef idx="2">
+            <a:schemeClr val="accent1"/>
+          </a:effectRef>
+          <a:fontRef idx="minor">
+            <a:schemeClr val="lt1"/>
+          </a:fontRef>
+        </p:style>
+        <p:txBody>
+          <a:bodyPr rtlCol="0" anchor="ctr"/>
+          <a:lstStyle/>
+          <a:p>
+            <a:pPr algn="ctr"/>
           </a:p>
         </p:txBody>
       </p:sp>
@@ -3695,7 +4015,7 @@
   <p:clrMapOvr>
     <a:masterClrMapping/>
   </p:clrMapOvr>
-  <p:transition spd="med" dur="648">
+  <p:transition spd="med" dur="428">
     <p:fade/>
   </p:transition>
 </p:sld>
@@ -3707,7 +4027,7 @@
     <p:bg>
       <p:bgPr>
         <a:solidFill>
-          <a:srgbClr val="1C2B3A"/>
+          <a:srgbClr val="0F1923"/>
         </a:solidFill>
         <a:effectLst/>
       </p:bgPr>
@@ -3721,20 +4041,22 @@
       <p:grpSpPr/>
       <p:sp>
         <p:nvSpPr>
-          <p:cNvPr id="2" name="Rectangle 1"/>
+          <p:cNvPr id="4" name="Oval 3"/>
           <p:cNvSpPr/>
           <p:nvPr/>
         </p:nvSpPr>
         <p:spPr>
           <a:xfrm>
-            <a:off x="0" y="5623560"/>
-            <a:ext cx="9144000" cy="1234440"/>
-          </a:xfrm>
-          <a:prstGeom prst="rect">
+            <a:off x="365760" y="4251960"/>
+            <a:ext cx="2560320" cy="2560320"/>
+          </a:xfrm>
+          <a:prstGeom prst="ellipse">
             <a:avLst/>
           </a:prstGeom>
           <a:solidFill>
-            <a:srgbClr val="C8A84B"/>
+            <a:srgbClr val="FFFFFF">
+              <a:alpha val="10000"/>
+            </a:srgbClr>
           </a:solidFill>
           <a:ln>
             <a:noFill/>
@@ -3764,20 +4086,22 @@
       </p:sp>
       <p:sp>
         <p:nvSpPr>
-          <p:cNvPr id="3" name="Rectangle 2"/>
+          <p:cNvPr id="3" name="Oval 2"/>
           <p:cNvSpPr/>
           <p:nvPr/>
         </p:nvSpPr>
         <p:spPr>
           <a:xfrm>
-            <a:off x="594360" y="1714500"/>
-            <a:ext cx="502920" cy="502920"/>
-          </a:xfrm>
-          <a:prstGeom prst="rect">
+            <a:off x="-914400" y="-914400"/>
+            <a:ext cx="4114800" cy="4114800"/>
+          </a:xfrm>
+          <a:prstGeom prst="ellipse">
             <a:avLst/>
           </a:prstGeom>
           <a:solidFill>
-            <a:srgbClr val="C8A84B"/>
+            <a:srgbClr val="FFFFFF">
+              <a:alpha val="8000"/>
+            </a:srgbClr>
           </a:solidFill>
           <a:ln>
             <a:noFill/>
@@ -3807,14 +4131,57 @@
       </p:sp>
       <p:sp>
         <p:nvSpPr>
-          <p:cNvPr id="4" name="TextBox 3"/>
+          <p:cNvPr id="2" name="Rectangle 1"/>
+          <p:cNvSpPr/>
+          <p:nvPr/>
+        </p:nvSpPr>
+        <p:spPr>
+          <a:xfrm>
+            <a:off x="0" y="0"/>
+            <a:ext cx="3840480" cy="6858000"/>
+          </a:xfrm>
+          <a:prstGeom prst="rect">
+            <a:avLst/>
+          </a:prstGeom>
+          <a:solidFill>
+            <a:srgbClr val="D4893A"/>
+          </a:solidFill>
+          <a:ln>
+            <a:noFill/>
+          </a:ln>
+        </p:spPr>
+        <p:style>
+          <a:lnRef idx="1">
+            <a:schemeClr val="accent1"/>
+          </a:lnRef>
+          <a:fillRef idx="3">
+            <a:schemeClr val="accent1"/>
+          </a:fillRef>
+          <a:effectRef idx="2">
+            <a:schemeClr val="accent1"/>
+          </a:effectRef>
+          <a:fontRef idx="minor">
+            <a:schemeClr val="lt1"/>
+          </a:fontRef>
+        </p:style>
+        <p:txBody>
+          <a:bodyPr rtlCol="0" anchor="ctr"/>
+          <a:lstStyle/>
+          <a:p>
+            <a:pPr algn="ctr"/>
+          </a:p>
+        </p:txBody>
+      </p:sp>
+      <p:sp>
+        <p:nvSpPr>
+          <p:cNvPr id="5" name="TextBox 4"/>
           <p:cNvSpPr txBox="1"/>
           <p:nvPr/>
         </p:nvSpPr>
         <p:spPr>
           <a:xfrm>
-            <a:off x="594360" y="1714500"/>
-            <a:ext cx="502920" cy="502920"/>
+            <a:off x="274320" y="1234440"/>
+            <a:ext cx="3474720" cy="3200400"/>
           </a:xfrm>
           <a:prstGeom prst="rect">
             <a:avLst/>
@@ -3822,32 +4189,79 @@
           <a:noFill/>
         </p:spPr>
         <p:txBody>
-          <a:bodyPr wrap="square"/>
+          <a:bodyPr wrap="square">
+            <a:spAutoFit/>
+          </a:bodyPr>
           <a:lstStyle/>
           <a:p>
             <a:pPr algn="ctr"/>
             <a:r>
-              <a:rPr sz="2600" b="1" i="0">
+              <a:rPr sz="11000" b="1" i="0">
                 <a:solidFill>
-                  <a:srgbClr val="1C2B3A"/>
+                  <a:srgbClr val="FFFFFF"/>
                 </a:solidFill>
                 <a:latin typeface="Georgia"/>
               </a:rPr>
-              <a:t>3</a:t>
-            </a:r>
-          </a:p>
-        </p:txBody>
-      </p:sp>
-      <p:sp>
-        <p:nvSpPr>
-          <p:cNvPr id="5" name="TextBox 4"/>
+              <a:t>01</a:t>
+            </a:r>
+          </a:p>
+        </p:txBody>
+      </p:sp>
+      <p:sp>
+        <p:nvSpPr>
+          <p:cNvPr id="6" name="Rectangle 5"/>
+          <p:cNvSpPr/>
+          <p:nvPr/>
+        </p:nvSpPr>
+        <p:spPr>
+          <a:xfrm>
+            <a:off x="3840480" y="1028700"/>
+            <a:ext cx="55000" cy="4800600"/>
+          </a:xfrm>
+          <a:prstGeom prst="rect">
+            <a:avLst/>
+          </a:prstGeom>
+          <a:solidFill>
+            <a:srgbClr val="FFFFFF">
+              <a:alpha val="25000"/>
+            </a:srgbClr>
+          </a:solidFill>
+          <a:ln>
+            <a:noFill/>
+          </a:ln>
+        </p:spPr>
+        <p:style>
+          <a:lnRef idx="1">
+            <a:schemeClr val="accent1"/>
+          </a:lnRef>
+          <a:fillRef idx="3">
+            <a:schemeClr val="accent1"/>
+          </a:fillRef>
+          <a:effectRef idx="2">
+            <a:schemeClr val="accent1"/>
+          </a:effectRef>
+          <a:fontRef idx="minor">
+            <a:schemeClr val="lt1"/>
+          </a:fontRef>
+        </p:style>
+        <p:txBody>
+          <a:bodyPr rtlCol="0" anchor="ctr"/>
+          <a:lstStyle/>
+          <a:p>
+            <a:pPr algn="ctr"/>
+          </a:p>
+        </p:txBody>
+      </p:sp>
+      <p:sp>
+        <p:nvSpPr>
+          <p:cNvPr id="7" name="TextBox 6"/>
           <p:cNvSpPr txBox="1"/>
           <p:nvPr/>
         </p:nvSpPr>
         <p:spPr>
           <a:xfrm>
-            <a:off x="1371600" y="1508760"/>
-            <a:ext cx="7178040" cy="1463040"/>
+            <a:off x="4023360" y="2057400"/>
+            <a:ext cx="4572000" cy="2011680"/>
           </a:xfrm>
           <a:prstGeom prst="rect">
             <a:avLst/>
@@ -3855,14 +4269,16 @@
           <a:noFill/>
         </p:spPr>
         <p:txBody>
-          <a:bodyPr wrap="square"/>
+          <a:bodyPr wrap="square">
+            <a:spAutoFit/>
+          </a:bodyPr>
           <a:lstStyle/>
           <a:p>
             <a:pPr algn="l"/>
             <a:r>
-              <a:rPr sz="4400" b="1" i="0">
+              <a:rPr sz="3800" b="1" i="0">
                 <a:solidFill>
-                  <a:srgbClr val="C8A84B"/>
+                  <a:srgbClr val="D4893A"/>
                 </a:solidFill>
                 <a:latin typeface="Georgia"/>
               </a:rPr>
@@ -3873,14 +4289,14 @@
       </p:sp>
       <p:sp>
         <p:nvSpPr>
-          <p:cNvPr id="6" name="TextBox 5"/>
+          <p:cNvPr id="8" name="TextBox 7"/>
           <p:cNvSpPr txBox="1"/>
           <p:nvPr/>
         </p:nvSpPr>
         <p:spPr>
           <a:xfrm>
-            <a:off x="594360" y="4251960"/>
-            <a:ext cx="7955280" cy="822960"/>
+            <a:off x="4023360" y="4663440"/>
+            <a:ext cx="4572000" cy="822960"/>
           </a:xfrm>
           <a:prstGeom prst="rect">
             <a:avLst/>
@@ -3888,14 +4304,16 @@
           <a:noFill/>
         </p:spPr>
         <p:txBody>
-          <a:bodyPr wrap="square"/>
+          <a:bodyPr wrap="square">
+            <a:spAutoFit/>
+          </a:bodyPr>
           <a:lstStyle/>
           <a:p>
             <a:pPr algn="l"/>
             <a:r>
-              <a:rPr sz="2000" b="0" i="1">
+              <a:rPr sz="1700" b="0" i="1">
                 <a:solidFill>
-                  <a:srgbClr val="FFFFFF"/>
+                  <a:srgbClr val="93979C"/>
                 </a:solidFill>
                 <a:latin typeface="Trebuchet MS"/>
               </a:rPr>
@@ -3909,7 +4327,7 @@
   <p:clrMapOvr>
     <a:masterClrMapping/>
   </p:clrMapOvr>
-  <p:transition spd="med" dur="413">
+  <p:transition spd="med" dur="487">
     <p:fade/>
   </p:transition>
 </p:sld>
@@ -3921,7 +4339,7 @@
     <p:bg>
       <p:bgPr>
         <a:solidFill>
-          <a:srgbClr val="1C2B3A"/>
+          <a:srgbClr val="0F1923"/>
         </a:solidFill>
         <a:effectLst/>
       </p:bgPr>
@@ -3935,20 +4353,22 @@
       <p:grpSpPr/>
       <p:sp>
         <p:nvSpPr>
-          <p:cNvPr id="2" name="Rectangle 1"/>
+          <p:cNvPr id="3" name="Oval 2"/>
           <p:cNvSpPr/>
           <p:nvPr/>
         </p:nvSpPr>
         <p:spPr>
           <a:xfrm>
-            <a:off x="0" y="0"/>
-            <a:ext cx="9144000" cy="548640"/>
-          </a:xfrm>
-          <a:prstGeom prst="rect">
+            <a:off x="2743200" y="1371600"/>
+            <a:ext cx="4800600" cy="4800600"/>
+          </a:xfrm>
+          <a:prstGeom prst="ellipse">
             <a:avLst/>
           </a:prstGeom>
           <a:solidFill>
-            <a:srgbClr val="C8A84B"/>
+            <a:srgbClr val="8AABB5">
+              <a:alpha val="14000"/>
+            </a:srgbClr>
           </a:solidFill>
           <a:ln>
             <a:noFill/>
@@ -3978,20 +4398,22 @@
       </p:sp>
       <p:sp>
         <p:nvSpPr>
-          <p:cNvPr id="3" name="Rectangle 2"/>
+          <p:cNvPr id="2" name="Oval 1"/>
           <p:cNvSpPr/>
           <p:nvPr/>
         </p:nvSpPr>
         <p:spPr>
           <a:xfrm>
-            <a:off x="0" y="0"/>
-            <a:ext cx="64008" cy="6858000"/>
-          </a:xfrm>
-          <a:prstGeom prst="rect">
+            <a:off x="457200" y="-685800"/>
+            <a:ext cx="8229600" cy="8229600"/>
+          </a:xfrm>
+          <a:prstGeom prst="ellipse">
             <a:avLst/>
           </a:prstGeom>
           <a:solidFill>
-            <a:srgbClr val="C8A84B"/>
+            <a:srgbClr val="D4893A">
+              <a:alpha val="12000"/>
+            </a:srgbClr>
           </a:solidFill>
           <a:ln>
             <a:noFill/>
@@ -4027,14 +4449,14 @@
         </p:nvSpPr>
         <p:spPr>
           <a:xfrm>
-            <a:off x="2286000" y="2880360"/>
-            <a:ext cx="4572000" cy="228600"/>
+            <a:off x="1371600" y="3017520"/>
+            <a:ext cx="6400800" cy="60000"/>
           </a:xfrm>
           <a:prstGeom prst="rect">
             <a:avLst/>
           </a:prstGeom>
           <a:solidFill>
-            <a:srgbClr val="C8A84B"/>
+            <a:srgbClr val="D4893A"/>
           </a:solidFill>
           <a:ln>
             <a:noFill/>
@@ -4070,8 +4492,8 @@
         </p:nvSpPr>
         <p:spPr>
           <a:xfrm>
-            <a:off x="1024128" y="3337560"/>
-            <a:ext cx="7525512" cy="1645920"/>
+            <a:off x="1097280" y="3107520"/>
+            <a:ext cx="6949440" cy="1828800"/>
           </a:xfrm>
           <a:prstGeom prst="rect">
             <a:avLst/>
@@ -4079,19 +4501,66 @@
           <a:noFill/>
         </p:spPr>
         <p:txBody>
-          <a:bodyPr wrap="square"/>
+          <a:bodyPr wrap="square">
+            <a:spAutoFit/>
+          </a:bodyPr>
           <a:lstStyle/>
           <a:p>
             <a:pPr algn="ctr"/>
             <a:r>
-              <a:rPr sz="4800" b="1" i="0">
+              <a:rPr sz="5400" b="1" i="0">
                 <a:solidFill>
-                  <a:srgbClr val="C8A84B"/>
+                  <a:srgbClr val="D4893A"/>
                 </a:solidFill>
                 <a:latin typeface="Georgia"/>
               </a:rPr>
               <a:t>Merci</a:t>
             </a:r>
+          </a:p>
+        </p:txBody>
+      </p:sp>
+      <p:sp>
+        <p:nvSpPr>
+          <p:cNvPr id="6" name="Rectangle 5"/>
+          <p:cNvSpPr/>
+          <p:nvPr/>
+        </p:nvSpPr>
+        <p:spPr>
+          <a:xfrm>
+            <a:off x="0" y="6748272"/>
+            <a:ext cx="9144000" cy="109728"/>
+          </a:xfrm>
+          <a:prstGeom prst="rect">
+            <a:avLst/>
+          </a:prstGeom>
+          <a:solidFill>
+            <a:srgbClr val="8AABB5">
+              <a:alpha val="80000"/>
+            </a:srgbClr>
+          </a:solidFill>
+          <a:ln>
+            <a:noFill/>
+          </a:ln>
+        </p:spPr>
+        <p:style>
+          <a:lnRef idx="1">
+            <a:schemeClr val="accent1"/>
+          </a:lnRef>
+          <a:fillRef idx="3">
+            <a:schemeClr val="accent1"/>
+          </a:fillRef>
+          <a:effectRef idx="2">
+            <a:schemeClr val="accent1"/>
+          </a:effectRef>
+          <a:fontRef idx="minor">
+            <a:schemeClr val="lt1"/>
+          </a:fontRef>
+        </p:style>
+        <p:txBody>
+          <a:bodyPr rtlCol="0" anchor="ctr"/>
+          <a:lstStyle/>
+          <a:p>
+            <a:pPr algn="ctr"/>
           </a:p>
         </p:txBody>
       </p:sp>
@@ -4100,7 +4569,7 @@
   <p:clrMapOvr>
     <a:masterClrMapping/>
   </p:clrMapOvr>
-  <p:transition spd="med" dur="678">
+  <p:transition spd="med" dur="498">
     <p:fade/>
   </p:transition>
 </p:sld>

</xml_diff>